<commit_message>
Assignment 2 is Done
</commit_message>
<xml_diff>
--- a/SDS.pptx
+++ b/SDS.pptx
@@ -5,10 +5,10 @@
     <p:sldMasterId id="2147483648" r:id="rId4"/>
   </p:sldMasterIdLst>
   <p:notesMasterIdLst>
-    <p:notesMasterId r:id="rId21"/>
+    <p:notesMasterId r:id="rId24"/>
   </p:notesMasterIdLst>
   <p:handoutMasterIdLst>
-    <p:handoutMasterId r:id="rId22"/>
+    <p:handoutMasterId r:id="rId25"/>
   </p:handoutMasterIdLst>
   <p:sldIdLst>
     <p:sldId id="256" r:id="rId5"/>
@@ -18,15 +18,18 @@
     <p:sldId id="303" r:id="rId9"/>
     <p:sldId id="291" r:id="rId10"/>
     <p:sldId id="289" r:id="rId11"/>
-    <p:sldId id="300" r:id="rId12"/>
-    <p:sldId id="290" r:id="rId13"/>
-    <p:sldId id="301" r:id="rId14"/>
-    <p:sldId id="302" r:id="rId15"/>
-    <p:sldId id="305" r:id="rId16"/>
-    <p:sldId id="304" r:id="rId17"/>
-    <p:sldId id="306" r:id="rId18"/>
-    <p:sldId id="307" r:id="rId19"/>
-    <p:sldId id="296" r:id="rId20"/>
+    <p:sldId id="310" r:id="rId12"/>
+    <p:sldId id="300" r:id="rId13"/>
+    <p:sldId id="290" r:id="rId14"/>
+    <p:sldId id="301" r:id="rId15"/>
+    <p:sldId id="313" r:id="rId16"/>
+    <p:sldId id="315" r:id="rId17"/>
+    <p:sldId id="314" r:id="rId18"/>
+    <p:sldId id="305" r:id="rId19"/>
+    <p:sldId id="304" r:id="rId20"/>
+    <p:sldId id="306" r:id="rId21"/>
+    <p:sldId id="307" r:id="rId22"/>
+    <p:sldId id="296" r:id="rId23"/>
   </p:sldIdLst>
   <p:sldSz cx="12192000" cy="6858000"/>
   <p:notesSz cx="6858000" cy="9144000"/>
@@ -835,7 +838,7 @@
           <a:p>
             <a:fld id="{F97DC217-DF71-1A49-B3EA-559F1F43B0FF}" type="slidenum">
               <a:rPr lang="en-US" smtClean="0"/>
-              <a:t>10</a:t>
+              <a:t>11</a:t>
             </a:fld>
             <a:endParaRPr lang="en-US" dirty="0"/>
           </a:p>
@@ -919,7 +922,7 @@
           <a:p>
             <a:fld id="{F97DC217-DF71-1A49-B3EA-559F1F43B0FF}" type="slidenum">
               <a:rPr lang="en-US" smtClean="0"/>
-              <a:t>11</a:t>
+              <a:t>16</a:t>
             </a:fld>
             <a:endParaRPr lang="en-US" dirty="0"/>
           </a:p>
@@ -928,7 +931,7 @@
     </p:spTree>
     <p:extLst>
       <p:ext uri="{BB962C8B-B14F-4D97-AF65-F5344CB8AC3E}">
-        <p14:creationId xmlns:p14="http://schemas.microsoft.com/office/powerpoint/2010/main" val="821221030"/>
+        <p14:creationId xmlns:p14="http://schemas.microsoft.com/office/powerpoint/2010/main" val="3779112914"/>
       </p:ext>
     </p:extLst>
   </p:cSld>
@@ -1003,91 +1006,7 @@
           <a:p>
             <a:fld id="{F97DC217-DF71-1A49-B3EA-559F1F43B0FF}" type="slidenum">
               <a:rPr lang="en-US" smtClean="0"/>
-              <a:t>13</a:t>
-            </a:fld>
-            <a:endParaRPr lang="en-US" dirty="0"/>
-          </a:p>
-        </p:txBody>
-      </p:sp>
-    </p:spTree>
-    <p:extLst>
-      <p:ext uri="{BB962C8B-B14F-4D97-AF65-F5344CB8AC3E}">
-        <p14:creationId xmlns:p14="http://schemas.microsoft.com/office/powerpoint/2010/main" val="3779112914"/>
-      </p:ext>
-    </p:extLst>
-  </p:cSld>
-  <p:clrMapOvr>
-    <a:masterClrMapping/>
-  </p:clrMapOvr>
-</p:notes>
-</file>
-
-<file path=ppt/notesSlides/notesSlide13.xml><?xml version="1.0" encoding="utf-8"?>
-<p:notes xmlns:a="http://schemas.openxmlformats.org/drawingml/2006/main" xmlns:r="http://schemas.openxmlformats.org/officeDocument/2006/relationships" xmlns:p="http://schemas.openxmlformats.org/presentationml/2006/main">
-  <p:cSld>
-    <p:spTree>
-      <p:nvGrpSpPr>
-        <p:cNvPr id="1" name=""/>
-        <p:cNvGrpSpPr/>
-        <p:nvPr/>
-      </p:nvGrpSpPr>
-      <p:grpSpPr>
-        <a:xfrm>
-          <a:off x="0" y="0"/>
-          <a:ext cx="0" cy="0"/>
-          <a:chOff x="0" y="0"/>
-          <a:chExt cx="0" cy="0"/>
-        </a:xfrm>
-      </p:grpSpPr>
-      <p:sp>
-        <p:nvSpPr>
-          <p:cNvPr id="2" name="Slide Image Placeholder 1"/>
-          <p:cNvSpPr>
-            <a:spLocks noGrp="1" noRot="1" noChangeAspect="1"/>
-          </p:cNvSpPr>
-          <p:nvPr>
-            <p:ph type="sldImg"/>
-          </p:nvPr>
-        </p:nvSpPr>
-        <p:spPr/>
-      </p:sp>
-      <p:sp>
-        <p:nvSpPr>
-          <p:cNvPr id="3" name="Notes Placeholder 2"/>
-          <p:cNvSpPr>
-            <a:spLocks noGrp="1"/>
-          </p:cNvSpPr>
-          <p:nvPr>
-            <p:ph type="body" idx="1"/>
-          </p:nvPr>
-        </p:nvSpPr>
-        <p:spPr/>
-        <p:txBody>
-          <a:bodyPr/>
-          <a:lstStyle/>
-          <a:p>
-            <a:endParaRPr lang="en-US" dirty="0"/>
-          </a:p>
-        </p:txBody>
-      </p:sp>
-      <p:sp>
-        <p:nvSpPr>
-          <p:cNvPr id="4" name="Slide Number Placeholder 3"/>
-          <p:cNvSpPr>
-            <a:spLocks noGrp="1"/>
-          </p:cNvSpPr>
-          <p:nvPr>
-            <p:ph type="sldNum" sz="quarter" idx="5"/>
-          </p:nvPr>
-        </p:nvSpPr>
-        <p:spPr/>
-        <p:txBody>
-          <a:bodyPr/>
-          <a:lstStyle/>
-          <a:p>
-            <a:fld id="{F97DC217-DF71-1A49-B3EA-559F1F43B0FF}" type="slidenum">
-              <a:rPr lang="en-US" smtClean="0"/>
-              <a:t>16</a:t>
+              <a:t>19</a:t>
             </a:fld>
             <a:endParaRPr lang="en-US" dirty="0"/>
           </a:p>
@@ -1675,7 +1594,7 @@
           <a:p>
             <a:fld id="{F97DC217-DF71-1A49-B3EA-559F1F43B0FF}" type="slidenum">
               <a:rPr lang="en-US" smtClean="0"/>
-              <a:t>8</a:t>
+              <a:t>9</a:t>
             </a:fld>
             <a:endParaRPr lang="en-US" dirty="0"/>
           </a:p>
@@ -1759,7 +1678,7 @@
           <a:p>
             <a:fld id="{F97DC217-DF71-1A49-B3EA-559F1F43B0FF}" type="slidenum">
               <a:rPr lang="en-US" smtClean="0"/>
-              <a:t>9</a:t>
+              <a:t>10</a:t>
             </a:fld>
             <a:endParaRPr lang="en-US" dirty="0"/>
           </a:p>
@@ -3614,872 +3533,6 @@
 </file>
 
 <file path=ppt/slideLayouts/slideLayout3.xml><?xml version="1.0" encoding="utf-8"?>
-<p:sldLayout xmlns:a="http://schemas.openxmlformats.org/drawingml/2006/main" xmlns:r="http://schemas.openxmlformats.org/officeDocument/2006/relationships" xmlns:p="http://schemas.openxmlformats.org/presentationml/2006/main" userDrawn="1">
-  <p:cSld name="Title and Right Image">
-    <p:spTree>
-      <p:nvGrpSpPr>
-        <p:cNvPr id="1" name=""/>
-        <p:cNvGrpSpPr/>
-        <p:nvPr/>
-      </p:nvGrpSpPr>
-      <p:grpSpPr>
-        <a:xfrm>
-          <a:off x="0" y="0"/>
-          <a:ext cx="0" cy="0"/>
-          <a:chOff x="0" y="0"/>
-          <a:chExt cx="0" cy="0"/>
-        </a:xfrm>
-      </p:grpSpPr>
-      <p:grpSp>
-        <p:nvGrpSpPr>
-          <p:cNvPr id="13" name="Group 12">
-            <a:extLst>
-              <a:ext uri="{FF2B5EF4-FFF2-40B4-BE49-F238E27FC236}">
-                <a16:creationId xmlns:a16="http://schemas.microsoft.com/office/drawing/2014/main" id="{AC10D125-AB73-D276-4947-94204736A30D}"/>
-              </a:ext>
-              <a:ext uri="{C183D7F6-B498-43B3-948B-1728B52AA6E4}">
-                <adec:decorative xmlns:adec="http://schemas.microsoft.com/office/drawing/2017/decorative" val="1"/>
-              </a:ext>
-            </a:extLst>
-          </p:cNvPr>
-          <p:cNvGrpSpPr/>
-          <p:nvPr userDrawn="1"/>
-        </p:nvGrpSpPr>
-        <p:grpSpPr>
-          <a:xfrm flipH="1">
-            <a:off x="1" y="0"/>
-            <a:ext cx="12191999" cy="6858000"/>
-            <a:chOff x="1" y="0"/>
-            <a:chExt cx="12191999" cy="6858000"/>
-          </a:xfrm>
-        </p:grpSpPr>
-        <p:sp>
-          <p:nvSpPr>
-            <p:cNvPr id="4" name="Freeform 3">
-              <a:extLst>
-                <a:ext uri="{FF2B5EF4-FFF2-40B4-BE49-F238E27FC236}">
-                  <a16:creationId xmlns:a16="http://schemas.microsoft.com/office/drawing/2014/main" id="{6A7F6A3F-E1DD-A246-9A6D-5F9B18BA2588}"/>
-                </a:ext>
-                <a:ext uri="{C183D7F6-B498-43B3-948B-1728B52AA6E4}">
-                  <adec:decorative xmlns:adec="http://schemas.microsoft.com/office/drawing/2017/decorative" val="1"/>
-                </a:ext>
-              </a:extLst>
-            </p:cNvPr>
-            <p:cNvSpPr/>
-            <p:nvPr userDrawn="1"/>
-          </p:nvSpPr>
-          <p:spPr>
-            <a:xfrm flipH="1">
-              <a:off x="8580896" y="1"/>
-              <a:ext cx="3611104" cy="3611104"/>
-            </a:xfrm>
-            <a:custGeom>
-              <a:avLst/>
-              <a:gdLst>
-                <a:gd name="connsiteX0" fmla="*/ 0 w 1167493"/>
-                <a:gd name="connsiteY0" fmla="*/ 0 h 1167493"/>
-                <a:gd name="connsiteX1" fmla="*/ 1167493 w 1167493"/>
-                <a:gd name="connsiteY1" fmla="*/ 0 h 1167493"/>
-                <a:gd name="connsiteX2" fmla="*/ 0 w 1167493"/>
-                <a:gd name="connsiteY2" fmla="*/ 1167493 h 1167493"/>
-                <a:gd name="connsiteX3" fmla="*/ 0 w 1167493"/>
-                <a:gd name="connsiteY3" fmla="*/ 0 h 1167493"/>
-              </a:gdLst>
-              <a:ahLst/>
-              <a:cxnLst>
-                <a:cxn ang="0">
-                  <a:pos x="connsiteX0" y="connsiteY0"/>
-                </a:cxn>
-                <a:cxn ang="0">
-                  <a:pos x="connsiteX1" y="connsiteY1"/>
-                </a:cxn>
-                <a:cxn ang="0">
-                  <a:pos x="connsiteX2" y="connsiteY2"/>
-                </a:cxn>
-                <a:cxn ang="0">
-                  <a:pos x="connsiteX3" y="connsiteY3"/>
-                </a:cxn>
-              </a:cxnLst>
-              <a:rect l="l" t="t" r="r" b="b"/>
-              <a:pathLst>
-                <a:path w="1167493" h="1167493">
-                  <a:moveTo>
-                    <a:pt x="0" y="0"/>
-                  </a:moveTo>
-                  <a:lnTo>
-                    <a:pt x="1167493" y="0"/>
-                  </a:lnTo>
-                  <a:cubicBezTo>
-                    <a:pt x="522704" y="0"/>
-                    <a:pt x="0" y="522704"/>
-                    <a:pt x="0" y="1167493"/>
-                  </a:cubicBezTo>
-                  <a:lnTo>
-                    <a:pt x="0" y="0"/>
-                  </a:lnTo>
-                  <a:close/>
-                </a:path>
-              </a:pathLst>
-            </a:custGeom>
-            <a:solidFill>
-              <a:schemeClr val="accent1"/>
-            </a:solidFill>
-            <a:ln>
-              <a:noFill/>
-            </a:ln>
-          </p:spPr>
-          <p:style>
-            <a:lnRef idx="2">
-              <a:schemeClr val="accent1">
-                <a:shade val="50000"/>
-              </a:schemeClr>
-            </a:lnRef>
-            <a:fillRef idx="1">
-              <a:schemeClr val="accent1"/>
-            </a:fillRef>
-            <a:effectRef idx="0">
-              <a:schemeClr val="accent1"/>
-            </a:effectRef>
-            <a:fontRef idx="minor">
-              <a:schemeClr val="lt1"/>
-            </a:fontRef>
-          </p:style>
-          <p:txBody>
-            <a:bodyPr wrap="square" rtlCol="0" anchor="ctr">
-              <a:noAutofit/>
-            </a:bodyPr>
-            <a:lstStyle/>
-            <a:p>
-              <a:pPr algn="ctr"/>
-              <a:endParaRPr lang="en-US" dirty="0"/>
-            </a:p>
-          </p:txBody>
-        </p:sp>
-        <p:sp>
-          <p:nvSpPr>
-            <p:cNvPr id="5" name="Freeform 4">
-              <a:extLst>
-                <a:ext uri="{FF2B5EF4-FFF2-40B4-BE49-F238E27FC236}">
-                  <a16:creationId xmlns:a16="http://schemas.microsoft.com/office/drawing/2014/main" id="{055FD0FC-C8FF-6741-A364-A29CDC6F9495}"/>
-                </a:ext>
-                <a:ext uri="{C183D7F6-B498-43B3-948B-1728B52AA6E4}">
-                  <adec:decorative xmlns:adec="http://schemas.microsoft.com/office/drawing/2017/decorative" val="1"/>
-                </a:ext>
-              </a:extLst>
-            </p:cNvPr>
-            <p:cNvSpPr/>
-            <p:nvPr userDrawn="1"/>
-          </p:nvSpPr>
-          <p:spPr>
-            <a:xfrm flipH="1">
-              <a:off x="8580896" y="3246896"/>
-              <a:ext cx="3611104" cy="3611104"/>
-            </a:xfrm>
-            <a:custGeom>
-              <a:avLst/>
-              <a:gdLst>
-                <a:gd name="connsiteX0" fmla="*/ 0 w 1167493"/>
-                <a:gd name="connsiteY0" fmla="*/ 0 h 1167493"/>
-                <a:gd name="connsiteX1" fmla="*/ 1167493 w 1167493"/>
-                <a:gd name="connsiteY1" fmla="*/ 1167493 h 1167493"/>
-                <a:gd name="connsiteX2" fmla="*/ 0 w 1167493"/>
-                <a:gd name="connsiteY2" fmla="*/ 1167493 h 1167493"/>
-                <a:gd name="connsiteX3" fmla="*/ 0 w 1167493"/>
-                <a:gd name="connsiteY3" fmla="*/ 0 h 1167493"/>
-              </a:gdLst>
-              <a:ahLst/>
-              <a:cxnLst>
-                <a:cxn ang="0">
-                  <a:pos x="connsiteX0" y="connsiteY0"/>
-                </a:cxn>
-                <a:cxn ang="0">
-                  <a:pos x="connsiteX1" y="connsiteY1"/>
-                </a:cxn>
-                <a:cxn ang="0">
-                  <a:pos x="connsiteX2" y="connsiteY2"/>
-                </a:cxn>
-                <a:cxn ang="0">
-                  <a:pos x="connsiteX3" y="connsiteY3"/>
-                </a:cxn>
-              </a:cxnLst>
-              <a:rect l="l" t="t" r="r" b="b"/>
-              <a:pathLst>
-                <a:path w="1167493" h="1167493">
-                  <a:moveTo>
-                    <a:pt x="0" y="0"/>
-                  </a:moveTo>
-                  <a:cubicBezTo>
-                    <a:pt x="0" y="644789"/>
-                    <a:pt x="522704" y="1167493"/>
-                    <a:pt x="1167493" y="1167493"/>
-                  </a:cubicBezTo>
-                  <a:lnTo>
-                    <a:pt x="0" y="1167493"/>
-                  </a:lnTo>
-                  <a:lnTo>
-                    <a:pt x="0" y="0"/>
-                  </a:lnTo>
-                  <a:close/>
-                </a:path>
-              </a:pathLst>
-            </a:custGeom>
-            <a:solidFill>
-              <a:schemeClr val="accent1"/>
-            </a:solidFill>
-            <a:ln>
-              <a:noFill/>
-            </a:ln>
-          </p:spPr>
-          <p:style>
-            <a:lnRef idx="2">
-              <a:schemeClr val="accent1">
-                <a:shade val="50000"/>
-              </a:schemeClr>
-            </a:lnRef>
-            <a:fillRef idx="1">
-              <a:schemeClr val="accent1"/>
-            </a:fillRef>
-            <a:effectRef idx="0">
-              <a:schemeClr val="accent1"/>
-            </a:effectRef>
-            <a:fontRef idx="minor">
-              <a:schemeClr val="lt1"/>
-            </a:fontRef>
-          </p:style>
-          <p:txBody>
-            <a:bodyPr wrap="square" rtlCol="0" anchor="ctr">
-              <a:noAutofit/>
-            </a:bodyPr>
-            <a:lstStyle/>
-            <a:p>
-              <a:pPr algn="ctr"/>
-              <a:endParaRPr lang="en-US" dirty="0">
-                <a:latin typeface="+mn-lt"/>
-              </a:endParaRPr>
-            </a:p>
-          </p:txBody>
-        </p:sp>
-        <p:sp>
-          <p:nvSpPr>
-            <p:cNvPr id="6" name="Freeform 5">
-              <a:extLst>
-                <a:ext uri="{FF2B5EF4-FFF2-40B4-BE49-F238E27FC236}">
-                  <a16:creationId xmlns:a16="http://schemas.microsoft.com/office/drawing/2014/main" id="{D11C9832-A021-954E-A34F-2988D1189AE9}"/>
-                </a:ext>
-                <a:ext uri="{C183D7F6-B498-43B3-948B-1728B52AA6E4}">
-                  <adec:decorative xmlns:adec="http://schemas.microsoft.com/office/drawing/2017/decorative" val="1"/>
-                </a:ext>
-              </a:extLst>
-            </p:cNvPr>
-            <p:cNvSpPr/>
-            <p:nvPr userDrawn="1"/>
-          </p:nvSpPr>
-          <p:spPr>
-            <a:xfrm>
-              <a:off x="1" y="0"/>
-              <a:ext cx="933856" cy="933856"/>
-            </a:xfrm>
-            <a:custGeom>
-              <a:avLst/>
-              <a:gdLst>
-                <a:gd name="connsiteX0" fmla="*/ 0 w 862693"/>
-                <a:gd name="connsiteY0" fmla="*/ 0 h 862693"/>
-                <a:gd name="connsiteX1" fmla="*/ 862693 w 862693"/>
-                <a:gd name="connsiteY1" fmla="*/ 0 h 862693"/>
-                <a:gd name="connsiteX2" fmla="*/ 0 w 862693"/>
-                <a:gd name="connsiteY2" fmla="*/ 862693 h 862693"/>
-                <a:gd name="connsiteX3" fmla="*/ 0 w 862693"/>
-                <a:gd name="connsiteY3" fmla="*/ 0 h 862693"/>
-              </a:gdLst>
-              <a:ahLst/>
-              <a:cxnLst>
-                <a:cxn ang="0">
-                  <a:pos x="connsiteX0" y="connsiteY0"/>
-                </a:cxn>
-                <a:cxn ang="0">
-                  <a:pos x="connsiteX1" y="connsiteY1"/>
-                </a:cxn>
-                <a:cxn ang="0">
-                  <a:pos x="connsiteX2" y="connsiteY2"/>
-                </a:cxn>
-                <a:cxn ang="0">
-                  <a:pos x="connsiteX3" y="connsiteY3"/>
-                </a:cxn>
-              </a:cxnLst>
-              <a:rect l="l" t="t" r="r" b="b"/>
-              <a:pathLst>
-                <a:path w="862693" h="862693">
-                  <a:moveTo>
-                    <a:pt x="0" y="0"/>
-                  </a:moveTo>
-                  <a:lnTo>
-                    <a:pt x="862693" y="0"/>
-                  </a:lnTo>
-                  <a:cubicBezTo>
-                    <a:pt x="862693" y="476453"/>
-                    <a:pt x="476452" y="862693"/>
-                    <a:pt x="0" y="862693"/>
-                  </a:cubicBezTo>
-                  <a:lnTo>
-                    <a:pt x="0" y="0"/>
-                  </a:lnTo>
-                  <a:close/>
-                </a:path>
-              </a:pathLst>
-            </a:custGeom>
-            <a:solidFill>
-              <a:schemeClr val="accent3"/>
-            </a:solidFill>
-            <a:ln>
-              <a:noFill/>
-            </a:ln>
-          </p:spPr>
-          <p:style>
-            <a:lnRef idx="2">
-              <a:schemeClr val="accent1">
-                <a:shade val="50000"/>
-              </a:schemeClr>
-            </a:lnRef>
-            <a:fillRef idx="1">
-              <a:schemeClr val="accent1"/>
-            </a:fillRef>
-            <a:effectRef idx="0">
-              <a:schemeClr val="accent1"/>
-            </a:effectRef>
-            <a:fontRef idx="minor">
-              <a:schemeClr val="lt1"/>
-            </a:fontRef>
-          </p:style>
-          <p:txBody>
-            <a:bodyPr wrap="square" rtlCol="0" anchor="ctr">
-              <a:noAutofit/>
-            </a:bodyPr>
-            <a:lstStyle/>
-            <a:p>
-              <a:pPr algn="ctr"/>
-              <a:endParaRPr lang="en-US" dirty="0"/>
-            </a:p>
-          </p:txBody>
-        </p:sp>
-        <p:grpSp>
-          <p:nvGrpSpPr>
-            <p:cNvPr id="9" name="Group 8">
-              <a:extLst>
-                <a:ext uri="{FF2B5EF4-FFF2-40B4-BE49-F238E27FC236}">
-                  <a16:creationId xmlns:a16="http://schemas.microsoft.com/office/drawing/2014/main" id="{9861BC34-DFBF-2D4F-B463-FCFBC08391FF}"/>
-                </a:ext>
-                <a:ext uri="{C183D7F6-B498-43B3-948B-1728B52AA6E4}">
-                  <adec:decorative xmlns:adec="http://schemas.microsoft.com/office/drawing/2017/decorative" val="1"/>
-                </a:ext>
-              </a:extLst>
-            </p:cNvPr>
-            <p:cNvGrpSpPr/>
-            <p:nvPr userDrawn="1"/>
-          </p:nvGrpSpPr>
-          <p:grpSpPr>
-            <a:xfrm>
-              <a:off x="8082092" y="5590903"/>
-              <a:ext cx="1572380" cy="1267097"/>
-              <a:chOff x="7413403" y="4976359"/>
-              <a:chExt cx="2334986" cy="1881641"/>
-            </a:xfrm>
-          </p:grpSpPr>
-          <p:sp>
-            <p:nvSpPr>
-              <p:cNvPr id="7" name="Freeform 6">
-                <a:extLst>
-                  <a:ext uri="{FF2B5EF4-FFF2-40B4-BE49-F238E27FC236}">
-                    <a16:creationId xmlns:a16="http://schemas.microsoft.com/office/drawing/2014/main" id="{55C37C19-F268-4A43-A0D4-3B1B38D48952}"/>
-                  </a:ext>
-                </a:extLst>
-              </p:cNvPr>
-              <p:cNvSpPr/>
-              <p:nvPr userDrawn="1"/>
-            </p:nvSpPr>
-            <p:spPr>
-              <a:xfrm rot="5400000" flipH="1" flipV="1">
-                <a:off x="8223822" y="5333433"/>
-                <a:ext cx="1881641" cy="1167493"/>
-              </a:xfrm>
-              <a:custGeom>
-                <a:avLst/>
-                <a:gdLst>
-                  <a:gd name="connsiteX0" fmla="*/ 1881641 w 1881641"/>
-                  <a:gd name="connsiteY0" fmla="*/ 1167473 h 1167493"/>
-                  <a:gd name="connsiteX1" fmla="*/ 1881641 w 1881641"/>
-                  <a:gd name="connsiteY1" fmla="*/ 1167493 h 1167493"/>
-                  <a:gd name="connsiteX2" fmla="*/ 1167493 w 1881641"/>
-                  <a:gd name="connsiteY2" fmla="*/ 1167493 h 1167493"/>
-                  <a:gd name="connsiteX3" fmla="*/ 0 w 1881641"/>
-                  <a:gd name="connsiteY3" fmla="*/ 0 h 1167493"/>
-                  <a:gd name="connsiteX4" fmla="*/ 714149 w 1881641"/>
-                  <a:gd name="connsiteY4" fmla="*/ 0 h 1167493"/>
-                  <a:gd name="connsiteX5" fmla="*/ 1875614 w 1881641"/>
-                  <a:gd name="connsiteY5" fmla="*/ 1048124 h 1167493"/>
-                  <a:gd name="connsiteX6" fmla="*/ 1881641 w 1881641"/>
-                  <a:gd name="connsiteY6" fmla="*/ 1167473 h 1167493"/>
-                </a:gdLst>
-                <a:ahLst/>
-                <a:cxnLst>
-                  <a:cxn ang="0">
-                    <a:pos x="connsiteX0" y="connsiteY0"/>
-                  </a:cxn>
-                  <a:cxn ang="0">
-                    <a:pos x="connsiteX1" y="connsiteY1"/>
-                  </a:cxn>
-                  <a:cxn ang="0">
-                    <a:pos x="connsiteX2" y="connsiteY2"/>
-                  </a:cxn>
-                  <a:cxn ang="0">
-                    <a:pos x="connsiteX3" y="connsiteY3"/>
-                  </a:cxn>
-                  <a:cxn ang="0">
-                    <a:pos x="connsiteX4" y="connsiteY4"/>
-                  </a:cxn>
-                  <a:cxn ang="0">
-                    <a:pos x="connsiteX5" y="connsiteY5"/>
-                  </a:cxn>
-                  <a:cxn ang="0">
-                    <a:pos x="connsiteX6" y="connsiteY6"/>
-                  </a:cxn>
-                </a:cxnLst>
-                <a:rect l="l" t="t" r="r" b="b"/>
-                <a:pathLst>
-                  <a:path w="1881641" h="1167493">
-                    <a:moveTo>
-                      <a:pt x="1881641" y="1167473"/>
-                    </a:moveTo>
-                    <a:lnTo>
-                      <a:pt x="1881641" y="1167493"/>
-                    </a:lnTo>
-                    <a:lnTo>
-                      <a:pt x="1167493" y="1167493"/>
-                    </a:lnTo>
-                    <a:cubicBezTo>
-                      <a:pt x="522704" y="1167493"/>
-                      <a:pt x="0" y="644789"/>
-                      <a:pt x="0" y="0"/>
-                    </a:cubicBezTo>
-                    <a:lnTo>
-                      <a:pt x="714149" y="0"/>
-                    </a:lnTo>
-                    <a:cubicBezTo>
-                      <a:pt x="1318639" y="0"/>
-                      <a:pt x="1815827" y="459408"/>
-                      <a:pt x="1875614" y="1048124"/>
-                    </a:cubicBezTo>
-                    <a:lnTo>
-                      <a:pt x="1881641" y="1167473"/>
-                    </a:lnTo>
-                    <a:close/>
-                  </a:path>
-                </a:pathLst>
-              </a:custGeom>
-              <a:solidFill>
-                <a:schemeClr val="accent1"/>
-              </a:solidFill>
-              <a:ln>
-                <a:noFill/>
-              </a:ln>
-            </p:spPr>
-            <p:style>
-              <a:lnRef idx="2">
-                <a:schemeClr val="accent1">
-                  <a:shade val="50000"/>
-                </a:schemeClr>
-              </a:lnRef>
-              <a:fillRef idx="1">
-                <a:schemeClr val="accent1"/>
-              </a:fillRef>
-              <a:effectRef idx="0">
-                <a:schemeClr val="accent1"/>
-              </a:effectRef>
-              <a:fontRef idx="minor">
-                <a:schemeClr val="lt1"/>
-              </a:fontRef>
-            </p:style>
-            <p:txBody>
-              <a:bodyPr wrap="square" rtlCol="0" anchor="ctr">
-                <a:noAutofit/>
-              </a:bodyPr>
-              <a:lstStyle/>
-              <a:p>
-                <a:pPr algn="ctr"/>
-                <a:endParaRPr lang="en-US" dirty="0">
-                  <a:latin typeface="+mn-lt"/>
-                </a:endParaRPr>
-              </a:p>
-            </p:txBody>
-          </p:sp>
-          <p:sp>
-            <p:nvSpPr>
-              <p:cNvPr id="8" name="Freeform 7">
-                <a:extLst>
-                  <a:ext uri="{FF2B5EF4-FFF2-40B4-BE49-F238E27FC236}">
-                    <a16:creationId xmlns:a16="http://schemas.microsoft.com/office/drawing/2014/main" id="{E4F760E5-9D5D-E44F-AEBF-20CA8DE87D11}"/>
-                  </a:ext>
-                </a:extLst>
-              </p:cNvPr>
-              <p:cNvSpPr/>
-              <p:nvPr userDrawn="1"/>
-            </p:nvSpPr>
-            <p:spPr>
-              <a:xfrm rot="16200000" flipV="1">
-                <a:off x="7056329" y="5333433"/>
-                <a:ext cx="1881641" cy="1167493"/>
-              </a:xfrm>
-              <a:custGeom>
-                <a:avLst/>
-                <a:gdLst>
-                  <a:gd name="connsiteX0" fmla="*/ 1881641 w 1881641"/>
-                  <a:gd name="connsiteY0" fmla="*/ 1167473 h 1167493"/>
-                  <a:gd name="connsiteX1" fmla="*/ 1881641 w 1881641"/>
-                  <a:gd name="connsiteY1" fmla="*/ 1167493 h 1167493"/>
-                  <a:gd name="connsiteX2" fmla="*/ 1167493 w 1881641"/>
-                  <a:gd name="connsiteY2" fmla="*/ 1167493 h 1167493"/>
-                  <a:gd name="connsiteX3" fmla="*/ 0 w 1881641"/>
-                  <a:gd name="connsiteY3" fmla="*/ 0 h 1167493"/>
-                  <a:gd name="connsiteX4" fmla="*/ 714149 w 1881641"/>
-                  <a:gd name="connsiteY4" fmla="*/ 0 h 1167493"/>
-                  <a:gd name="connsiteX5" fmla="*/ 1875614 w 1881641"/>
-                  <a:gd name="connsiteY5" fmla="*/ 1048124 h 1167493"/>
-                  <a:gd name="connsiteX6" fmla="*/ 1881641 w 1881641"/>
-                  <a:gd name="connsiteY6" fmla="*/ 1167473 h 1167493"/>
-                </a:gdLst>
-                <a:ahLst/>
-                <a:cxnLst>
-                  <a:cxn ang="0">
-                    <a:pos x="connsiteX0" y="connsiteY0"/>
-                  </a:cxn>
-                  <a:cxn ang="0">
-                    <a:pos x="connsiteX1" y="connsiteY1"/>
-                  </a:cxn>
-                  <a:cxn ang="0">
-                    <a:pos x="connsiteX2" y="connsiteY2"/>
-                  </a:cxn>
-                  <a:cxn ang="0">
-                    <a:pos x="connsiteX3" y="connsiteY3"/>
-                  </a:cxn>
-                  <a:cxn ang="0">
-                    <a:pos x="connsiteX4" y="connsiteY4"/>
-                  </a:cxn>
-                  <a:cxn ang="0">
-                    <a:pos x="connsiteX5" y="connsiteY5"/>
-                  </a:cxn>
-                  <a:cxn ang="0">
-                    <a:pos x="connsiteX6" y="connsiteY6"/>
-                  </a:cxn>
-                </a:cxnLst>
-                <a:rect l="l" t="t" r="r" b="b"/>
-                <a:pathLst>
-                  <a:path w="1881641" h="1167493">
-                    <a:moveTo>
-                      <a:pt x="1881641" y="1167473"/>
-                    </a:moveTo>
-                    <a:lnTo>
-                      <a:pt x="1881641" y="1167493"/>
-                    </a:lnTo>
-                    <a:lnTo>
-                      <a:pt x="1167493" y="1167493"/>
-                    </a:lnTo>
-                    <a:cubicBezTo>
-                      <a:pt x="522704" y="1167493"/>
-                      <a:pt x="0" y="644789"/>
-                      <a:pt x="0" y="0"/>
-                    </a:cubicBezTo>
-                    <a:lnTo>
-                      <a:pt x="714149" y="0"/>
-                    </a:lnTo>
-                    <a:cubicBezTo>
-                      <a:pt x="1318639" y="0"/>
-                      <a:pt x="1815827" y="459408"/>
-                      <a:pt x="1875614" y="1048124"/>
-                    </a:cubicBezTo>
-                    <a:lnTo>
-                      <a:pt x="1881641" y="1167473"/>
-                    </a:lnTo>
-                    <a:close/>
-                  </a:path>
-                </a:pathLst>
-              </a:custGeom>
-              <a:solidFill>
-                <a:schemeClr val="tx2"/>
-              </a:solidFill>
-              <a:ln>
-                <a:noFill/>
-              </a:ln>
-            </p:spPr>
-            <p:style>
-              <a:lnRef idx="2">
-                <a:schemeClr val="accent1">
-                  <a:shade val="50000"/>
-                </a:schemeClr>
-              </a:lnRef>
-              <a:fillRef idx="1">
-                <a:schemeClr val="accent1"/>
-              </a:fillRef>
-              <a:effectRef idx="0">
-                <a:schemeClr val="accent1"/>
-              </a:effectRef>
-              <a:fontRef idx="minor">
-                <a:schemeClr val="lt1"/>
-              </a:fontRef>
-            </p:style>
-            <p:txBody>
-              <a:bodyPr wrap="square" rtlCol="0" anchor="ctr">
-                <a:noAutofit/>
-              </a:bodyPr>
-              <a:lstStyle/>
-              <a:p>
-                <a:pPr algn="ctr"/>
-                <a:endParaRPr lang="en-US" dirty="0">
-                  <a:latin typeface="+mn-lt"/>
-                </a:endParaRPr>
-              </a:p>
-            </p:txBody>
-          </p:sp>
-        </p:grpSp>
-      </p:grpSp>
-      <p:sp>
-        <p:nvSpPr>
-          <p:cNvPr id="2" name="Title 1">
-            <a:extLst>
-              <a:ext uri="{FF2B5EF4-FFF2-40B4-BE49-F238E27FC236}">
-                <a16:creationId xmlns:a16="http://schemas.microsoft.com/office/drawing/2014/main" id="{3CD97974-B93C-4C96-B3F6-F69E3D6DE6CA}"/>
-              </a:ext>
-            </a:extLst>
-          </p:cNvPr>
-          <p:cNvSpPr>
-            <a:spLocks noGrp="1"/>
-          </p:cNvSpPr>
-          <p:nvPr>
-            <p:ph type="title" hasCustomPrompt="1"/>
-          </p:nvPr>
-        </p:nvSpPr>
-        <p:spPr>
-          <a:xfrm>
-            <a:off x="1167492" y="1371600"/>
-            <a:ext cx="5486400" cy="4114800"/>
-          </a:xfrm>
-        </p:spPr>
-        <p:txBody>
-          <a:bodyPr anchor="ctr" anchorCtr="0">
-            <a:noAutofit/>
-          </a:bodyPr>
-          <a:lstStyle>
-            <a:lvl1pPr>
-              <a:defRPr sz="6000" b="1">
-                <a:latin typeface="+mj-lt"/>
-              </a:defRPr>
-            </a:lvl1pPr>
-          </a:lstStyle>
-          <a:p>
-            <a:r>
-              <a:rPr lang="en-US" dirty="0"/>
-              <a:t>Click to add title</a:t>
-            </a:r>
-          </a:p>
-        </p:txBody>
-      </p:sp>
-      <p:sp>
-        <p:nvSpPr>
-          <p:cNvPr id="15" name="Picture Placeholder 14">
-            <a:extLst>
-              <a:ext uri="{FF2B5EF4-FFF2-40B4-BE49-F238E27FC236}">
-                <a16:creationId xmlns:a16="http://schemas.microsoft.com/office/drawing/2014/main" id="{3124234B-E1C4-2616-9993-A23142AA69B2}"/>
-              </a:ext>
-            </a:extLst>
-          </p:cNvPr>
-          <p:cNvSpPr>
-            <a:spLocks noGrp="1"/>
-          </p:cNvSpPr>
-          <p:nvPr>
-            <p:ph type="pic" sz="quarter" idx="10"/>
-          </p:nvPr>
-        </p:nvSpPr>
-        <p:spPr>
-          <a:xfrm>
-            <a:off x="7183438" y="1168400"/>
-            <a:ext cx="4500562" cy="4521200"/>
-          </a:xfrm>
-          <a:prstGeom prst="ellipse">
-            <a:avLst/>
-          </a:prstGeom>
-          <a:solidFill>
-            <a:schemeClr val="accent2"/>
-          </a:solidFill>
-        </p:spPr>
-        <p:txBody>
-          <a:bodyPr/>
-          <a:lstStyle>
-            <a:lvl1pPr marL="0" indent="0" algn="ctr">
-              <a:buNone/>
-              <a:defRPr sz="2000"/>
-            </a:lvl1pPr>
-          </a:lstStyle>
-          <a:p>
-            <a:r>
-              <a:rPr lang="en-US"/>
-              <a:t>Click icon to add picture</a:t>
-            </a:r>
-            <a:endParaRPr lang="en-US" dirty="0"/>
-          </a:p>
-        </p:txBody>
-      </p:sp>
-      <p:sp>
-        <p:nvSpPr>
-          <p:cNvPr id="10" name="Date Placeholder 3">
-            <a:extLst>
-              <a:ext uri="{FF2B5EF4-FFF2-40B4-BE49-F238E27FC236}">
-                <a16:creationId xmlns:a16="http://schemas.microsoft.com/office/drawing/2014/main" id="{7536C149-3EFE-A94E-902D-57CED00B2C0F}"/>
-              </a:ext>
-            </a:extLst>
-          </p:cNvPr>
-          <p:cNvSpPr>
-            <a:spLocks noGrp="1"/>
-          </p:cNvSpPr>
-          <p:nvPr>
-            <p:ph type="dt" sz="half" idx="2"/>
-          </p:nvPr>
-        </p:nvSpPr>
-        <p:spPr>
-          <a:xfrm>
-            <a:off x="381000" y="6356350"/>
-            <a:ext cx="2743200" cy="365125"/>
-          </a:xfrm>
-          <a:prstGeom prst="rect">
-            <a:avLst/>
-          </a:prstGeom>
-        </p:spPr>
-        <p:txBody>
-          <a:bodyPr vert="horz" lIns="91440" tIns="45720" rIns="91440" bIns="45720" rtlCol="0" anchor="ctr">
-            <a:noAutofit/>
-          </a:bodyPr>
-          <a:lstStyle>
-            <a:lvl1pPr algn="l">
-              <a:defRPr sz="1200">
-                <a:solidFill>
-                  <a:schemeClr val="accent3"/>
-                </a:solidFill>
-                <a:latin typeface="+mn-lt"/>
-              </a:defRPr>
-            </a:lvl1pPr>
-          </a:lstStyle>
-          <a:p>
-            <a:r>
-              <a:rPr lang="en-US" dirty="0"/>
-              <a:t>9/8/20XX</a:t>
-            </a:r>
-          </a:p>
-        </p:txBody>
-      </p:sp>
-      <p:sp>
-        <p:nvSpPr>
-          <p:cNvPr id="11" name="Footer Placeholder 4">
-            <a:extLst>
-              <a:ext uri="{FF2B5EF4-FFF2-40B4-BE49-F238E27FC236}">
-                <a16:creationId xmlns:a16="http://schemas.microsoft.com/office/drawing/2014/main" id="{53CA1E78-F17D-F34D-9F81-0DBF44F37894}"/>
-              </a:ext>
-            </a:extLst>
-          </p:cNvPr>
-          <p:cNvSpPr>
-            <a:spLocks noGrp="1"/>
-          </p:cNvSpPr>
-          <p:nvPr>
-            <p:ph type="ftr" sz="quarter" idx="3"/>
-          </p:nvPr>
-        </p:nvSpPr>
-        <p:spPr>
-          <a:xfrm>
-            <a:off x="4038600" y="6356350"/>
-            <a:ext cx="4114800" cy="365125"/>
-          </a:xfrm>
-          <a:prstGeom prst="rect">
-            <a:avLst/>
-          </a:prstGeom>
-        </p:spPr>
-        <p:txBody>
-          <a:bodyPr vert="horz" lIns="91440" tIns="45720" rIns="91440" bIns="45720" rtlCol="0" anchor="ctr">
-            <a:noAutofit/>
-          </a:bodyPr>
-          <a:lstStyle>
-            <a:lvl1pPr algn="ctr">
-              <a:defRPr sz="1200">
-                <a:solidFill>
-                  <a:schemeClr val="accent3"/>
-                </a:solidFill>
-                <a:latin typeface="+mn-lt"/>
-              </a:defRPr>
-            </a:lvl1pPr>
-          </a:lstStyle>
-          <a:p>
-            <a:endParaRPr lang="en-US" dirty="0"/>
-          </a:p>
-        </p:txBody>
-      </p:sp>
-      <p:sp>
-        <p:nvSpPr>
-          <p:cNvPr id="12" name="Slide Number Placeholder 5">
-            <a:extLst>
-              <a:ext uri="{FF2B5EF4-FFF2-40B4-BE49-F238E27FC236}">
-                <a16:creationId xmlns:a16="http://schemas.microsoft.com/office/drawing/2014/main" id="{1FE54918-A625-F64F-A42E-A427E9B2D489}"/>
-              </a:ext>
-            </a:extLst>
-          </p:cNvPr>
-          <p:cNvSpPr>
-            <a:spLocks noGrp="1"/>
-          </p:cNvSpPr>
-          <p:nvPr>
-            <p:ph type="sldNum" sz="quarter" idx="4"/>
-          </p:nvPr>
-        </p:nvSpPr>
-        <p:spPr>
-          <a:xfrm>
-            <a:off x="10153276" y="6356350"/>
-            <a:ext cx="1657723" cy="365125"/>
-          </a:xfrm>
-          <a:prstGeom prst="rect">
-            <a:avLst/>
-          </a:prstGeom>
-        </p:spPr>
-        <p:txBody>
-          <a:bodyPr vert="horz" lIns="91440" tIns="45720" rIns="91440" bIns="45720" rtlCol="0" anchor="ctr">
-            <a:noAutofit/>
-          </a:bodyPr>
-          <a:lstStyle>
-            <a:lvl1pPr algn="r">
-              <a:defRPr sz="1200">
-                <a:solidFill>
-                  <a:schemeClr val="accent2"/>
-                </a:solidFill>
-                <a:latin typeface="+mn-lt"/>
-              </a:defRPr>
-            </a:lvl1pPr>
-          </a:lstStyle>
-          <a:p>
-            <a:fld id="{294A09A9-5501-47C1-A89A-A340965A2BE2}" type="slidenum">
-              <a:rPr lang="en-US" smtClean="0"/>
-              <a:pPr/>
-              <a:t>‹#›</a:t>
-            </a:fld>
-            <a:endParaRPr lang="en-US" dirty="0"/>
-          </a:p>
-        </p:txBody>
-      </p:sp>
-    </p:spTree>
-    <p:extLst>
-      <p:ext uri="{BB962C8B-B14F-4D97-AF65-F5344CB8AC3E}">
-        <p14:creationId xmlns:p14="http://schemas.microsoft.com/office/powerpoint/2010/main" val="2491266794"/>
-      </p:ext>
-    </p:extLst>
-  </p:cSld>
-  <p:clrMapOvr>
-    <a:masterClrMapping/>
-  </p:clrMapOvr>
-</p:sldLayout>
-</file>
-
-<file path=ppt/slideLayouts/slideLayout4.xml><?xml version="1.0" encoding="utf-8"?>
 <p:sldLayout xmlns:a="http://schemas.openxmlformats.org/drawingml/2006/main" xmlns:r="http://schemas.openxmlformats.org/officeDocument/2006/relationships" xmlns:p="http://schemas.openxmlformats.org/presentationml/2006/main" preserve="1" userDrawn="1">
   <p:cSld name="Title and content 2">
     <p:bg>
@@ -5205,7 +4258,7 @@
 </p:sldLayout>
 </file>
 
-<file path=ppt/slideLayouts/slideLayout5.xml><?xml version="1.0" encoding="utf-8"?>
+<file path=ppt/slideLayouts/slideLayout4.xml><?xml version="1.0" encoding="utf-8"?>
 <p:sldLayout xmlns:a="http://schemas.openxmlformats.org/drawingml/2006/main" xmlns:r="http://schemas.openxmlformats.org/officeDocument/2006/relationships" xmlns:p="http://schemas.openxmlformats.org/presentationml/2006/main" type="title" preserve="1">
   <p:cSld name="Section title">
     <p:spTree>
@@ -5955,7 +5008,7 @@
 </p:sldLayout>
 </file>
 
-<file path=ppt/slideLayouts/slideLayout6.xml><?xml version="1.0" encoding="utf-8"?>
+<file path=ppt/slideLayouts/slideLayout5.xml><?xml version="1.0" encoding="utf-8"?>
 <p:sldLayout xmlns:a="http://schemas.openxmlformats.org/drawingml/2006/main" xmlns:r="http://schemas.openxmlformats.org/officeDocument/2006/relationships" xmlns:p="http://schemas.openxmlformats.org/presentationml/2006/main" preserve="1" userDrawn="1">
   <p:cSld name="Title and 2 Column Content">
     <p:spTree>
@@ -6992,7 +6045,7 @@
 </p:sldLayout>
 </file>
 
-<file path=ppt/slideLayouts/slideLayout7.xml><?xml version="1.0" encoding="utf-8"?>
+<file path=ppt/slideLayouts/slideLayout6.xml><?xml version="1.0" encoding="utf-8"?>
 <p:sldLayout xmlns:a="http://schemas.openxmlformats.org/drawingml/2006/main" xmlns:r="http://schemas.openxmlformats.org/officeDocument/2006/relationships" xmlns:p="http://schemas.openxmlformats.org/presentationml/2006/main" preserve="1" userDrawn="1">
   <p:cSld name="Title and 2 content">
     <p:bg>
@@ -7696,7 +6749,7 @@
 </p:sldLayout>
 </file>
 
-<file path=ppt/slideLayouts/slideLayout8.xml><?xml version="1.0" encoding="utf-8"?>
+<file path=ppt/slideLayouts/slideLayout7.xml><?xml version="1.0" encoding="utf-8"?>
 <p:sldLayout xmlns:a="http://schemas.openxmlformats.org/drawingml/2006/main" xmlns:r="http://schemas.openxmlformats.org/officeDocument/2006/relationships" xmlns:p="http://schemas.openxmlformats.org/presentationml/2006/main" type="obj" preserve="1">
   <p:cSld name="Chart ">
     <p:bg>
@@ -8284,7 +7337,7 @@
 </p:sldLayout>
 </file>
 
-<file path=ppt/slideLayouts/slideLayout9.xml><?xml version="1.0" encoding="utf-8"?>
+<file path=ppt/slideLayouts/slideLayout8.xml><?xml version="1.0" encoding="utf-8"?>
 <p:sldLayout xmlns:a="http://schemas.openxmlformats.org/drawingml/2006/main" xmlns:r="http://schemas.openxmlformats.org/officeDocument/2006/relationships" xmlns:p="http://schemas.openxmlformats.org/presentationml/2006/main" type="title" preserve="1">
   <p:cSld name="End Slide">
     <p:spTree>
@@ -9300,13 +8353,12 @@
   <p:sldLayoutIdLst>
     <p:sldLayoutId id="2147483649" r:id="rId1"/>
     <p:sldLayoutId id="2147483650" r:id="rId2"/>
-    <p:sldLayoutId id="2147483673" r:id="rId3"/>
-    <p:sldLayoutId id="2147483671" r:id="rId4"/>
-    <p:sldLayoutId id="2147483659" r:id="rId5"/>
-    <p:sldLayoutId id="2147483668" r:id="rId6"/>
-    <p:sldLayoutId id="2147483669" r:id="rId7"/>
-    <p:sldLayoutId id="2147483661" r:id="rId8"/>
-    <p:sldLayoutId id="2147483666" r:id="rId9"/>
+    <p:sldLayoutId id="2147483671" r:id="rId3"/>
+    <p:sldLayoutId id="2147483659" r:id="rId4"/>
+    <p:sldLayoutId id="2147483668" r:id="rId5"/>
+    <p:sldLayoutId id="2147483669" r:id="rId6"/>
+    <p:sldLayoutId id="2147483661" r:id="rId7"/>
+    <p:sldLayoutId id="2147483666" r:id="rId8"/>
   </p:sldLayoutIdLst>
   <p:hf sldNum="0" hdr="0" ftr="0" dt="0"/>
   <p:txStyles>
@@ -9786,6 +8838,354 @@
           <a:p>
             <a:r>
               <a:rPr lang="en-US" dirty="0"/>
+              <a:t>SOLID Principles</a:t>
+            </a:r>
+          </a:p>
+        </p:txBody>
+      </p:sp>
+      <p:sp>
+        <p:nvSpPr>
+          <p:cNvPr id="8" name="Rectangle 2">
+            <a:extLst>
+              <a:ext uri="{FF2B5EF4-FFF2-40B4-BE49-F238E27FC236}">
+                <a16:creationId xmlns:a16="http://schemas.microsoft.com/office/drawing/2014/main" id="{C18C8363-1151-CA2E-E25A-AAE513C9627F}"/>
+              </a:ext>
+            </a:extLst>
+          </p:cNvPr>
+          <p:cNvSpPr>
+            <a:spLocks noGrp="1" noChangeArrowheads="1"/>
+          </p:cNvSpPr>
+          <p:nvPr>
+            <p:ph idx="1"/>
+          </p:nvPr>
+        </p:nvSpPr>
+        <p:spPr bwMode="auto">
+          <a:xfrm>
+            <a:off x="1166813" y="2489815"/>
+            <a:ext cx="9353703" cy="2400657"/>
+          </a:xfrm>
+          <a:prstGeom prst="rect">
+            <a:avLst/>
+          </a:prstGeom>
+          <a:noFill/>
+          <a:ln>
+            <a:noFill/>
+          </a:ln>
+          <a:effectLst/>
+          <a:extLst>
+            <a:ext uri="{909E8E84-426E-40DD-AFC4-6F175D3DCCD1}">
+              <a14:hiddenFill xmlns:a14="http://schemas.microsoft.com/office/drawing/2010/main">
+                <a:solidFill>
+                  <a:schemeClr val="accent1"/>
+                </a:solidFill>
+              </a14:hiddenFill>
+            </a:ext>
+            <a:ext uri="{91240B29-F687-4F45-9708-019B960494DF}">
+              <a14:hiddenLine xmlns:a14="http://schemas.microsoft.com/office/drawing/2010/main" w="9525">
+                <a:solidFill>
+                  <a:schemeClr val="tx1"/>
+                </a:solidFill>
+                <a:miter lim="800000"/>
+                <a:headEnd/>
+                <a:tailEnd/>
+              </a14:hiddenLine>
+            </a:ext>
+            <a:ext uri="{AF507438-7753-43E0-B8FC-AC1667EBCBE1}">
+              <a14:hiddenEffects xmlns:a14="http://schemas.microsoft.com/office/drawing/2010/main">
+                <a:effectLst>
+                  <a:outerShdw dist="35921" dir="2700000" algn="ctr" rotWithShape="0">
+                    <a:schemeClr val="bg2"/>
+                  </a:outerShdw>
+                </a:effectLst>
+              </a14:hiddenEffects>
+            </a:ext>
+          </a:extLst>
+        </p:spPr>
+        <p:txBody>
+          <a:bodyPr vert="horz" wrap="square" lIns="91440" tIns="45720" rIns="91440" bIns="45720" numCol="1" anchor="ctr" anchorCtr="0" compatLnSpc="1">
+            <a:prstTxWarp prst="textNoShape">
+              <a:avLst/>
+            </a:prstTxWarp>
+            <a:spAutoFit/>
+          </a:bodyPr>
+          <a:lstStyle/>
+          <a:p>
+            <a:pPr marL="0" marR="0" lvl="0" indent="0" algn="l" defTabSz="914400" rtl="0" eaLnBrk="0" fontAlgn="base" latinLnBrk="0" hangingPunct="0">
+              <a:lnSpc>
+                <a:spcPct val="100000"/>
+              </a:lnSpc>
+              <a:spcBef>
+                <a:spcPct val="0"/>
+              </a:spcBef>
+              <a:spcAft>
+                <a:spcPct val="0"/>
+              </a:spcAft>
+              <a:buClrTx/>
+              <a:buSzTx/>
+              <a:buFontTx/>
+              <a:buNone/>
+              <a:tabLst/>
+            </a:pPr>
+            <a:r>
+              <a:rPr kumimoji="0" lang="en-US" altLang="en-US" sz="2500" b="0" i="0" u="none" strike="noStrike" cap="none" normalizeH="0" baseline="0" dirty="0">
+                <a:ln>
+                  <a:noFill/>
+                </a:ln>
+                <a:solidFill>
+                  <a:schemeClr val="tx1"/>
+                </a:solidFill>
+                <a:effectLst/>
+                <a:latin typeface="Arial" panose="020B0604020202020204" pitchFamily="34" charset="0"/>
+              </a:rPr>
+              <a:t>Applies all five SOLID principles for clean and maintainable code.</a:t>
+            </a:r>
+            <a:br>
+              <a:rPr kumimoji="0" lang="en-US" altLang="en-US" sz="2500" b="0" i="0" u="none" strike="noStrike" cap="none" normalizeH="0" baseline="0" dirty="0">
+                <a:ln>
+                  <a:noFill/>
+                </a:ln>
+                <a:solidFill>
+                  <a:schemeClr val="tx1"/>
+                </a:solidFill>
+                <a:effectLst/>
+                <a:latin typeface="Arial" panose="020B0604020202020204" pitchFamily="34" charset="0"/>
+              </a:rPr>
+            </a:br>
+            <a:r>
+              <a:rPr kumimoji="0" lang="en-US" altLang="en-US" sz="2500" b="0" i="0" u="none" strike="noStrike" cap="none" normalizeH="0" baseline="0" dirty="0">
+                <a:ln>
+                  <a:noFill/>
+                </a:ln>
+                <a:solidFill>
+                  <a:schemeClr val="tx1"/>
+                </a:solidFill>
+                <a:effectLst/>
+                <a:latin typeface="Arial" panose="020B0604020202020204" pitchFamily="34" charset="0"/>
+              </a:rPr>
+              <a:t>Example: </a:t>
+            </a:r>
+            <a:r>
+              <a:rPr kumimoji="0" lang="en-US" altLang="en-US" sz="2500" b="1" i="0" u="none" strike="noStrike" cap="none" normalizeH="0" baseline="0" dirty="0" err="1">
+                <a:ln>
+                  <a:noFill/>
+                </a:ln>
+                <a:solidFill>
+                  <a:schemeClr val="tx1"/>
+                </a:solidFill>
+                <a:effectLst/>
+                <a:latin typeface="Arial Unicode MS"/>
+              </a:rPr>
+              <a:t>AuthManager</a:t>
+            </a:r>
+            <a:r>
+              <a:rPr kumimoji="0" lang="en-US" altLang="en-US" sz="2500" b="0" i="0" u="none" strike="noStrike" cap="none" normalizeH="0" baseline="0" dirty="0">
+                <a:ln>
+                  <a:noFill/>
+                </a:ln>
+                <a:solidFill>
+                  <a:schemeClr val="tx1"/>
+                </a:solidFill>
+                <a:effectLst/>
+              </a:rPr>
+              <a:t> follows </a:t>
+            </a:r>
+            <a:r>
+              <a:rPr kumimoji="0" lang="en-US" altLang="en-US" sz="2500" b="1" i="0" u="none" strike="noStrike" cap="none" normalizeH="0" baseline="0" dirty="0">
+                <a:ln>
+                  <a:noFill/>
+                </a:ln>
+                <a:solidFill>
+                  <a:schemeClr val="tx1"/>
+                </a:solidFill>
+                <a:effectLst/>
+              </a:rPr>
+              <a:t>Single Responsibility</a:t>
+            </a:r>
+            <a:r>
+              <a:rPr kumimoji="0" lang="en-US" altLang="en-US" sz="2500" b="0" i="0" u="none" strike="noStrike" cap="none" normalizeH="0" baseline="0" dirty="0">
+                <a:ln>
+                  <a:noFill/>
+                </a:ln>
+                <a:solidFill>
+                  <a:schemeClr val="tx1"/>
+                </a:solidFill>
+                <a:effectLst/>
+              </a:rPr>
+              <a:t>, and </a:t>
+            </a:r>
+            <a:r>
+              <a:rPr kumimoji="0" lang="en-US" altLang="en-US" sz="2500" b="1" i="0" u="none" strike="noStrike" cap="none" normalizeH="0" baseline="0" dirty="0" err="1">
+                <a:ln>
+                  <a:noFill/>
+                </a:ln>
+                <a:solidFill>
+                  <a:schemeClr val="tx1"/>
+                </a:solidFill>
+                <a:effectLst/>
+                <a:latin typeface="Arial Unicode MS"/>
+              </a:rPr>
+              <a:t>IManager</a:t>
+            </a:r>
+            <a:r>
+              <a:rPr kumimoji="0" lang="en-US" altLang="en-US" sz="2500" b="0" i="0" u="none" strike="noStrike" cap="none" normalizeH="0" baseline="0" dirty="0">
+                <a:ln>
+                  <a:noFill/>
+                </a:ln>
+                <a:solidFill>
+                  <a:schemeClr val="tx1"/>
+                </a:solidFill>
+                <a:effectLst/>
+              </a:rPr>
+              <a:t> supports </a:t>
+            </a:r>
+            <a:r>
+              <a:rPr kumimoji="0" lang="en-US" altLang="en-US" sz="2500" b="1" i="0" u="none" strike="noStrike" cap="none" normalizeH="0" baseline="0" dirty="0">
+                <a:ln>
+                  <a:noFill/>
+                </a:ln>
+                <a:solidFill>
+                  <a:schemeClr val="tx1"/>
+                </a:solidFill>
+                <a:effectLst/>
+              </a:rPr>
+              <a:t>Interface Segregation</a:t>
+            </a:r>
+            <a:r>
+              <a:rPr kumimoji="0" lang="en-US" altLang="en-US" sz="2500" b="0" i="0" u="none" strike="noStrike" cap="none" normalizeH="0" baseline="0" dirty="0">
+                <a:ln>
+                  <a:noFill/>
+                </a:ln>
+                <a:solidFill>
+                  <a:schemeClr val="tx1"/>
+                </a:solidFill>
+                <a:effectLst/>
+              </a:rPr>
+              <a:t>.</a:t>
+            </a:r>
+            <a:br>
+              <a:rPr kumimoji="0" lang="en-US" altLang="en-US" sz="2500" b="0" i="0" u="none" strike="noStrike" cap="none" normalizeH="0" baseline="0" dirty="0">
+                <a:ln>
+                  <a:noFill/>
+                </a:ln>
+                <a:solidFill>
+                  <a:schemeClr val="tx1"/>
+                </a:solidFill>
+                <a:effectLst/>
+                <a:latin typeface="Arial" panose="020B0604020202020204" pitchFamily="34" charset="0"/>
+              </a:rPr>
+            </a:br>
+            <a:r>
+              <a:rPr kumimoji="0" lang="en-US" altLang="en-US" sz="2500" b="1" i="0" u="none" strike="noStrike" cap="none" normalizeH="0" baseline="0" dirty="0">
+                <a:ln>
+                  <a:noFill/>
+                </a:ln>
+                <a:solidFill>
+                  <a:schemeClr val="tx1"/>
+                </a:solidFill>
+                <a:effectLst/>
+                <a:latin typeface="Arial" panose="020B0604020202020204" pitchFamily="34" charset="0"/>
+              </a:rPr>
+              <a:t>Open/Closed principle </a:t>
+            </a:r>
+            <a:r>
+              <a:rPr kumimoji="0" lang="en-US" altLang="en-US" sz="2500" b="0" i="0" u="none" strike="noStrike" cap="none" normalizeH="0" baseline="0" dirty="0">
+                <a:ln>
+                  <a:noFill/>
+                </a:ln>
+                <a:solidFill>
+                  <a:schemeClr val="tx1"/>
+                </a:solidFill>
+                <a:effectLst/>
+                <a:latin typeface="Arial" panose="020B0604020202020204" pitchFamily="34" charset="0"/>
+              </a:rPr>
+              <a:t>is applied by extending without modifying existing classes.</a:t>
+            </a:r>
+            <a:br>
+              <a:rPr kumimoji="0" lang="en-US" altLang="en-US" sz="2500" b="0" i="0" u="none" strike="noStrike" cap="none" normalizeH="0" baseline="0" dirty="0">
+                <a:ln>
+                  <a:noFill/>
+                </a:ln>
+                <a:solidFill>
+                  <a:schemeClr val="tx1"/>
+                </a:solidFill>
+                <a:effectLst/>
+                <a:latin typeface="Arial" panose="020B0604020202020204" pitchFamily="34" charset="0"/>
+              </a:rPr>
+            </a:br>
+            <a:r>
+              <a:rPr kumimoji="0" lang="en-US" altLang="en-US" sz="2500" b="0" i="0" u="none" strike="noStrike" cap="none" normalizeH="0" baseline="0" dirty="0">
+                <a:ln>
+                  <a:noFill/>
+                </a:ln>
+                <a:solidFill>
+                  <a:schemeClr val="tx1"/>
+                </a:solidFill>
+                <a:effectLst/>
+                <a:latin typeface="Arial" panose="020B0604020202020204" pitchFamily="34" charset="0"/>
+              </a:rPr>
+              <a:t>Encourages modular, testable, and scalable design. </a:t>
+            </a:r>
+          </a:p>
+        </p:txBody>
+      </p:sp>
+    </p:spTree>
+    <p:extLst>
+      <p:ext uri="{BB962C8B-B14F-4D97-AF65-F5344CB8AC3E}">
+        <p14:creationId xmlns:p14="http://schemas.microsoft.com/office/powerpoint/2010/main" val="1265939620"/>
+      </p:ext>
+    </p:extLst>
+  </p:cSld>
+  <p:clrMapOvr>
+    <a:masterClrMapping/>
+  </p:clrMapOvr>
+</p:sld>
+</file>
+
+<file path=ppt/slides/slide11.xml><?xml version="1.0" encoding="utf-8"?>
+<p:sld xmlns:a="http://schemas.openxmlformats.org/drawingml/2006/main" xmlns:r="http://schemas.openxmlformats.org/officeDocument/2006/relationships" xmlns:p="http://schemas.openxmlformats.org/presentationml/2006/main">
+  <p:cSld>
+    <p:spTree>
+      <p:nvGrpSpPr>
+        <p:cNvPr id="1" name=""/>
+        <p:cNvGrpSpPr/>
+        <p:nvPr/>
+      </p:nvGrpSpPr>
+      <p:grpSpPr>
+        <a:xfrm>
+          <a:off x="0" y="0"/>
+          <a:ext cx="0" cy="0"/>
+          <a:chOff x="0" y="0"/>
+          <a:chExt cx="0" cy="0"/>
+        </a:xfrm>
+      </p:grpSpPr>
+      <p:sp>
+        <p:nvSpPr>
+          <p:cNvPr id="6" name="Title 5">
+            <a:extLst>
+              <a:ext uri="{FF2B5EF4-FFF2-40B4-BE49-F238E27FC236}">
+                <a16:creationId xmlns:a16="http://schemas.microsoft.com/office/drawing/2014/main" id="{EDF9E134-98AA-3ECE-E40A-180C85ACD7D5}"/>
+              </a:ext>
+            </a:extLst>
+          </p:cNvPr>
+          <p:cNvSpPr>
+            <a:spLocks noGrp="1"/>
+          </p:cNvSpPr>
+          <p:nvPr>
+            <p:ph type="title"/>
+          </p:nvPr>
+        </p:nvSpPr>
+        <p:spPr>
+          <a:xfrm>
+            <a:off x="1167492" y="136526"/>
+            <a:ext cx="9601200" cy="1653371"/>
+          </a:xfrm>
+        </p:spPr>
+        <p:txBody>
+          <a:bodyPr/>
+          <a:lstStyle/>
+          <a:p>
+            <a:r>
+              <a:rPr lang="en-US" dirty="0"/>
               <a:t>Design Patterns</a:t>
             </a:r>
           </a:p>
@@ -10155,7 +9555,7 @@
 </p:sld>
 </file>
 
-<file path=ppt/slides/slide11.xml><?xml version="1.0" encoding="utf-8"?>
+<file path=ppt/slides/slide12.xml><?xml version="1.0" encoding="utf-8"?>
 <p:sld xmlns:a="http://schemas.openxmlformats.org/drawingml/2006/main" xmlns:r="http://schemas.openxmlformats.org/officeDocument/2006/relationships" xmlns:p="http://schemas.openxmlformats.org/presentationml/2006/main">
   <p:cSld>
     <p:spTree>
@@ -10174,10 +9574,160 @@
       </p:grpSpPr>
       <p:sp>
         <p:nvSpPr>
-          <p:cNvPr id="6" name="Title 5">
+          <p:cNvPr id="2" name="Title 1">
             <a:extLst>
               <a:ext uri="{FF2B5EF4-FFF2-40B4-BE49-F238E27FC236}">
-                <a16:creationId xmlns:a16="http://schemas.microsoft.com/office/drawing/2014/main" id="{EDF9E134-98AA-3ECE-E40A-180C85ACD7D5}"/>
+                <a16:creationId xmlns:a16="http://schemas.microsoft.com/office/drawing/2014/main" id="{0B6CD689-6D4F-BB1A-A6F4-07BE1A603C95}"/>
+              </a:ext>
+            </a:extLst>
+          </p:cNvPr>
+          <p:cNvSpPr>
+            <a:spLocks noGrp="1"/>
+          </p:cNvSpPr>
+          <p:nvPr>
+            <p:ph type="ctrTitle"/>
+          </p:nvPr>
+        </p:nvSpPr>
+        <p:spPr>
+          <a:xfrm>
+            <a:off x="223520" y="232913"/>
+            <a:ext cx="10302240" cy="3830130"/>
+          </a:xfrm>
+        </p:spPr>
+        <p:txBody>
+          <a:bodyPr/>
+          <a:lstStyle/>
+          <a:p>
+            <a:r>
+              <a:rPr lang="en-US" dirty="0"/>
+              <a:t>Overview of the Application</a:t>
+            </a:r>
+          </a:p>
+        </p:txBody>
+      </p:sp>
+    </p:spTree>
+    <p:extLst>
+      <p:ext uri="{BB962C8B-B14F-4D97-AF65-F5344CB8AC3E}">
+        <p14:creationId xmlns:p14="http://schemas.microsoft.com/office/powerpoint/2010/main" val="2023152231"/>
+      </p:ext>
+    </p:extLst>
+  </p:cSld>
+  <p:clrMapOvr>
+    <a:masterClrMapping/>
+  </p:clrMapOvr>
+</p:sld>
+</file>
+
+<file path=ppt/slides/slide13.xml><?xml version="1.0" encoding="utf-8"?>
+<p:sld xmlns:a="http://schemas.openxmlformats.org/drawingml/2006/main" xmlns:r="http://schemas.openxmlformats.org/officeDocument/2006/relationships" xmlns:p="http://schemas.openxmlformats.org/presentationml/2006/main">
+  <p:cSld>
+    <p:spTree>
+      <p:nvGrpSpPr>
+        <p:cNvPr id="1" name=""/>
+        <p:cNvGrpSpPr/>
+        <p:nvPr/>
+      </p:nvGrpSpPr>
+      <p:grpSpPr>
+        <a:xfrm>
+          <a:off x="0" y="0"/>
+          <a:ext cx="0" cy="0"/>
+          <a:chOff x="0" y="0"/>
+          <a:chExt cx="0" cy="0"/>
+        </a:xfrm>
+      </p:grpSpPr>
+      <p:sp>
+        <p:nvSpPr>
+          <p:cNvPr id="2" name="Title 1">
+            <a:extLst>
+              <a:ext uri="{FF2B5EF4-FFF2-40B4-BE49-F238E27FC236}">
+                <a16:creationId xmlns:a16="http://schemas.microsoft.com/office/drawing/2014/main" id="{42296B85-1FDD-BA9C-02FA-FCBBD2C87150}"/>
+              </a:ext>
+            </a:extLst>
+          </p:cNvPr>
+          <p:cNvSpPr>
+            <a:spLocks noGrp="1"/>
+          </p:cNvSpPr>
+          <p:nvPr>
+            <p:ph type="title"/>
+          </p:nvPr>
+        </p:nvSpPr>
+        <p:spPr/>
+        <p:txBody>
+          <a:bodyPr/>
+          <a:lstStyle/>
+          <a:p>
+            <a:r>
+              <a:rPr lang="en-US" dirty="0"/>
+              <a:t>The application is made by C# and connecting to database</a:t>
+            </a:r>
+          </a:p>
+        </p:txBody>
+      </p:sp>
+      <p:pic>
+        <p:nvPicPr>
+          <p:cNvPr id="5" name="Content Placeholder 4">
+            <a:extLst>
+              <a:ext uri="{FF2B5EF4-FFF2-40B4-BE49-F238E27FC236}">
+                <a16:creationId xmlns:a16="http://schemas.microsoft.com/office/drawing/2014/main" id="{6A209F6D-AE96-3853-F675-8031621BF6F0}"/>
+              </a:ext>
+            </a:extLst>
+          </p:cNvPr>
+          <p:cNvPicPr>
+            <a:picLocks noGrp="1" noChangeAspect="1"/>
+          </p:cNvPicPr>
+          <p:nvPr>
+            <p:ph idx="1"/>
+          </p:nvPr>
+        </p:nvPicPr>
+        <p:blipFill>
+          <a:blip r:embed="rId2"/>
+          <a:stretch>
+            <a:fillRect/>
+          </a:stretch>
+        </p:blipFill>
+        <p:spPr>
+          <a:xfrm>
+            <a:off x="1523512" y="1793441"/>
+            <a:ext cx="8233552" cy="4942273"/>
+          </a:xfrm>
+        </p:spPr>
+      </p:pic>
+    </p:spTree>
+    <p:extLst>
+      <p:ext uri="{BB962C8B-B14F-4D97-AF65-F5344CB8AC3E}">
+        <p14:creationId xmlns:p14="http://schemas.microsoft.com/office/powerpoint/2010/main" val="4034286451"/>
+      </p:ext>
+    </p:extLst>
+  </p:cSld>
+  <p:clrMapOvr>
+    <a:masterClrMapping/>
+  </p:clrMapOvr>
+</p:sld>
+</file>
+
+<file path=ppt/slides/slide14.xml><?xml version="1.0" encoding="utf-8"?>
+<p:sld xmlns:a="http://schemas.openxmlformats.org/drawingml/2006/main" xmlns:r="http://schemas.openxmlformats.org/officeDocument/2006/relationships" xmlns:p="http://schemas.openxmlformats.org/presentationml/2006/main">
+  <p:cSld>
+    <p:spTree>
+      <p:nvGrpSpPr>
+        <p:cNvPr id="1" name=""/>
+        <p:cNvGrpSpPr/>
+        <p:nvPr/>
+      </p:nvGrpSpPr>
+      <p:grpSpPr>
+        <a:xfrm>
+          <a:off x="0" y="0"/>
+          <a:ext cx="0" cy="0"/>
+          <a:chOff x="0" y="0"/>
+          <a:chExt cx="0" cy="0"/>
+        </a:xfrm>
+      </p:grpSpPr>
+      <p:sp>
+        <p:nvSpPr>
+          <p:cNvPr id="10" name="Title 1">
+            <a:extLst>
+              <a:ext uri="{FF2B5EF4-FFF2-40B4-BE49-F238E27FC236}">
+                <a16:creationId xmlns:a16="http://schemas.microsoft.com/office/drawing/2014/main" id="{9FB4C0AE-FAED-29E0-1A76-D0EA32AE0895}"/>
               </a:ext>
             </a:extLst>
           </p:cNvPr>
@@ -10191,7 +9741,7 @@
         <p:spPr>
           <a:xfrm>
             <a:off x="1167492" y="136526"/>
-            <a:ext cx="9601200" cy="1653371"/>
+            <a:ext cx="9779183" cy="1570038"/>
           </a:xfrm>
         </p:spPr>
         <p:txBody>
@@ -10200,152 +9750,44 @@
           <a:p>
             <a:r>
               <a:rPr lang="en-US" dirty="0"/>
-              <a:t>Tools </a:t>
+              <a:t>Home Page &amp; Budgeting Page</a:t>
             </a:r>
           </a:p>
         </p:txBody>
       </p:sp>
-      <p:sp>
-        <p:nvSpPr>
-          <p:cNvPr id="3" name="Content Placeholder 2">
+      <p:pic>
+        <p:nvPicPr>
+          <p:cNvPr id="9" name="Content Placeholder 8">
             <a:extLst>
               <a:ext uri="{FF2B5EF4-FFF2-40B4-BE49-F238E27FC236}">
-                <a16:creationId xmlns:a16="http://schemas.microsoft.com/office/drawing/2014/main" id="{C932D3B2-9041-250A-B758-072CFA39DFB6}"/>
+                <a16:creationId xmlns:a16="http://schemas.microsoft.com/office/drawing/2014/main" id="{DBE3E360-3F44-47C2-8483-3233BF44B799}"/>
               </a:ext>
             </a:extLst>
           </p:cNvPr>
-          <p:cNvSpPr>
-            <a:spLocks noGrp="1" noChangeArrowheads="1"/>
-          </p:cNvSpPr>
+          <p:cNvPicPr>
+            <a:picLocks noGrp="1" noChangeAspect="1"/>
+          </p:cNvPicPr>
           <p:nvPr>
             <p:ph idx="1"/>
           </p:nvPr>
-        </p:nvSpPr>
-        <p:spPr bwMode="auto">
+        </p:nvPicPr>
+        <p:blipFill>
+          <a:blip r:embed="rId2"/>
+          <a:stretch>
+            <a:fillRect/>
+          </a:stretch>
+        </p:blipFill>
+        <p:spPr>
           <a:xfrm>
-            <a:off x="907871" y="2520574"/>
-            <a:ext cx="10376258" cy="1631216"/>
+            <a:off x="1380852" y="1872791"/>
+            <a:ext cx="8677548" cy="4848683"/>
           </a:xfrm>
-          <a:prstGeom prst="rect">
-            <a:avLst/>
-          </a:prstGeom>
-          <a:noFill/>
-          <a:ln>
-            <a:noFill/>
-          </a:ln>
-          <a:effectLst/>
-          <a:extLst>
-            <a:ext uri="{909E8E84-426E-40DD-AFC4-6F175D3DCCD1}">
-              <a14:hiddenFill xmlns:a14="http://schemas.microsoft.com/office/drawing/2010/main">
-                <a:solidFill>
-                  <a:schemeClr val="accent1"/>
-                </a:solidFill>
-              </a14:hiddenFill>
-            </a:ext>
-            <a:ext uri="{91240B29-F687-4F45-9708-019B960494DF}">
-              <a14:hiddenLine xmlns:a14="http://schemas.microsoft.com/office/drawing/2010/main" w="9525">
-                <a:solidFill>
-                  <a:schemeClr val="tx1"/>
-                </a:solidFill>
-                <a:miter lim="800000"/>
-                <a:headEnd/>
-                <a:tailEnd/>
-              </a14:hiddenLine>
-            </a:ext>
-            <a:ext uri="{AF507438-7753-43E0-B8FC-AC1667EBCBE1}">
-              <a14:hiddenEffects xmlns:a14="http://schemas.microsoft.com/office/drawing/2010/main">
-                <a:effectLst>
-                  <a:outerShdw dist="35921" dir="2700000" algn="ctr" rotWithShape="0">
-                    <a:schemeClr val="bg2"/>
-                  </a:outerShdw>
-                </a:effectLst>
-              </a14:hiddenEffects>
-            </a:ext>
-          </a:extLst>
         </p:spPr>
-        <p:txBody>
-          <a:bodyPr vert="horz" wrap="square" lIns="91440" tIns="45720" rIns="91440" bIns="45720" numCol="1" anchor="ctr" anchorCtr="0" compatLnSpc="1">
-            <a:prstTxWarp prst="textNoShape">
-              <a:avLst/>
-            </a:prstTxWarp>
-            <a:spAutoFit/>
-          </a:bodyPr>
-          <a:lstStyle/>
-          <a:p>
-            <a:pPr marL="0" marR="0" lvl="0" indent="0" algn="l" defTabSz="914400" rtl="0" eaLnBrk="0" fontAlgn="base" latinLnBrk="0" hangingPunct="0">
-              <a:lnSpc>
-                <a:spcPct val="100000"/>
-              </a:lnSpc>
-              <a:spcBef>
-                <a:spcPct val="0"/>
-              </a:spcBef>
-              <a:spcAft>
-                <a:spcPct val="0"/>
-              </a:spcAft>
-              <a:buClrTx/>
-              <a:buSzTx/>
-              <a:buFontTx/>
-              <a:buNone/>
-              <a:tabLst/>
-            </a:pPr>
-            <a:r>
-              <a:rPr lang="en-US" sz="2500" dirty="0"/>
-              <a:t>Used </a:t>
-            </a:r>
-            <a:r>
-              <a:rPr lang="en-US" sz="2500" b="1" dirty="0"/>
-              <a:t>Draw.io</a:t>
-            </a:r>
-            <a:r>
-              <a:rPr lang="en-US" sz="2500" dirty="0"/>
-              <a:t> and </a:t>
-            </a:r>
-            <a:r>
-              <a:rPr lang="en-US" sz="2500" b="1" dirty="0" err="1"/>
-              <a:t>PlantUML</a:t>
-            </a:r>
-            <a:r>
-              <a:rPr lang="en-US" sz="2500" dirty="0"/>
-              <a:t> for diagrams and modeling.</a:t>
-            </a:r>
-            <a:br>
-              <a:rPr lang="en-US" sz="2500" dirty="0"/>
-            </a:br>
-            <a:r>
-              <a:rPr lang="en-US" sz="2500" dirty="0"/>
-              <a:t>These tools ensure clear and professional visual documentation.</a:t>
-            </a:r>
-            <a:br>
-              <a:rPr lang="en-US" sz="2500" dirty="0"/>
-            </a:br>
-            <a:r>
-              <a:rPr lang="en-US" sz="2500" dirty="0"/>
-              <a:t>Support team collaboration and iterative design.</a:t>
-            </a:r>
-            <a:br>
-              <a:rPr lang="en-US" sz="2500" dirty="0"/>
-            </a:br>
-            <a:r>
-              <a:rPr lang="en-US" sz="2500" dirty="0"/>
-              <a:t>Helpful for maintaining a unified design standard throughout the project.</a:t>
-            </a:r>
-            <a:endParaRPr kumimoji="0" lang="en-US" altLang="en-US" sz="2500" b="0" i="0" u="none" strike="noStrike" cap="none" normalizeH="0" baseline="0" dirty="0">
-              <a:ln>
-                <a:noFill/>
-              </a:ln>
-              <a:solidFill>
-                <a:schemeClr val="tx1"/>
-              </a:solidFill>
-              <a:effectLst/>
-              <a:latin typeface="Arial" panose="020B0604020202020204" pitchFamily="34" charset="0"/>
-            </a:endParaRPr>
-          </a:p>
-        </p:txBody>
-      </p:sp>
+      </p:pic>
     </p:spTree>
     <p:extLst>
       <p:ext uri="{BB962C8B-B14F-4D97-AF65-F5344CB8AC3E}">
-        <p14:creationId xmlns:p14="http://schemas.microsoft.com/office/powerpoint/2010/main" val="1224352256"/>
+        <p14:creationId xmlns:p14="http://schemas.microsoft.com/office/powerpoint/2010/main" val="118318436"/>
       </p:ext>
     </p:extLst>
   </p:cSld>
@@ -10355,7 +9797,7 @@
 </p:sld>
 </file>
 
-<file path=ppt/slides/slide12.xml><?xml version="1.0" encoding="utf-8"?>
+<file path=ppt/slides/slide15.xml><?xml version="1.0" encoding="utf-8"?>
 <p:sld xmlns:a="http://schemas.openxmlformats.org/drawingml/2006/main" xmlns:r="http://schemas.openxmlformats.org/officeDocument/2006/relationships" xmlns:p="http://schemas.openxmlformats.org/presentationml/2006/main">
   <p:cSld>
     <p:spTree>
@@ -10418,7 +9860,7 @@
 </p:sld>
 </file>
 
-<file path=ppt/slides/slide13.xml><?xml version="1.0" encoding="utf-8"?>
+<file path=ppt/slides/slide16.xml><?xml version="1.0" encoding="utf-8"?>
 <p:sld xmlns:a="http://schemas.openxmlformats.org/drawingml/2006/main" xmlns:r="http://schemas.openxmlformats.org/officeDocument/2006/relationships" xmlns:p="http://schemas.openxmlformats.org/presentationml/2006/main">
   <p:cSld>
     <p:spTree>
@@ -10612,7 +10054,7 @@
 </p:sld>
 </file>
 
-<file path=ppt/slides/slide14.xml><?xml version="1.0" encoding="utf-8"?>
+<file path=ppt/slides/slide17.xml><?xml version="1.0" encoding="utf-8"?>
 <p:sld xmlns:a="http://schemas.openxmlformats.org/drawingml/2006/main" xmlns:r="http://schemas.openxmlformats.org/officeDocument/2006/relationships" xmlns:p="http://schemas.openxmlformats.org/presentationml/2006/main">
   <p:cSld>
     <p:spTree>
@@ -10732,7 +10174,7 @@
 </p:sld>
 </file>
 
-<file path=ppt/slides/slide15.xml><?xml version="1.0" encoding="utf-8"?>
+<file path=ppt/slides/slide18.xml><?xml version="1.0" encoding="utf-8"?>
 <p:sld xmlns:a="http://schemas.openxmlformats.org/drawingml/2006/main" xmlns:r="http://schemas.openxmlformats.org/officeDocument/2006/relationships" xmlns:p="http://schemas.openxmlformats.org/presentationml/2006/main">
   <p:cSld>
     <p:spTree>
@@ -10832,7 +10274,7 @@
 </p:sld>
 </file>
 
-<file path=ppt/slides/slide16.xml><?xml version="1.0" encoding="utf-8"?>
+<file path=ppt/slides/slide19.xml><?xml version="1.0" encoding="utf-8"?>
 <p:sld xmlns:a="http://schemas.openxmlformats.org/drawingml/2006/main" xmlns:r="http://schemas.openxmlformats.org/officeDocument/2006/relationships" xmlns:p="http://schemas.openxmlformats.org/presentationml/2006/main">
   <p:cSld>
     <p:spTree>
@@ -12649,17 +12091,30 @@
               <a:tabLst/>
             </a:pPr>
             <a:r>
+              <a:rPr lang="en-US" altLang="en-US" sz="1800" dirty="0">
+                <a:solidFill>
+                  <a:schemeClr val="bg1">
+                    <a:lumMod val="95000"/>
+                  </a:schemeClr>
+                </a:solidFill>
+                <a:latin typeface="Arial" panose="020B0604020202020204" pitchFamily="34" charset="0"/>
+              </a:rPr>
+              <a:t>Ill</a:t>
+            </a:r>
+            <a:r>
               <a:rPr kumimoji="0" lang="en-US" altLang="en-US" sz="1800" b="0" i="0" u="none" strike="noStrike" cap="none" normalizeH="0" baseline="0" dirty="0">
                 <a:ln>
                   <a:noFill/>
                 </a:ln>
                 <a:solidFill>
-                  <a:schemeClr val="tx1"/>
+                  <a:schemeClr val="bg1">
+                    <a:lumMod val="95000"/>
+                  </a:schemeClr>
                 </a:solidFill>
                 <a:effectLst/>
                 <a:latin typeface="Arial" panose="020B0604020202020204" pitchFamily="34" charset="0"/>
               </a:rPr>
-              <a:t>Illustrate interactions between system components for specific user stories.</a:t>
+              <a:t>ustrate interactions between system components for specific user stories.</a:t>
             </a:r>
             <a:br>
               <a:rPr kumimoji="0" lang="en-US" altLang="en-US" sz="1800" b="0" i="0" u="none" strike="noStrike" cap="none" normalizeH="0" baseline="0" dirty="0">
@@ -12667,7 +12122,9 @@
                   <a:noFill/>
                 </a:ln>
                 <a:solidFill>
-                  <a:schemeClr val="tx1"/>
+                  <a:schemeClr val="bg1">
+                    <a:lumMod val="95000"/>
+                  </a:schemeClr>
                 </a:solidFill>
                 <a:effectLst/>
                 <a:latin typeface="Arial" panose="020B0604020202020204" pitchFamily="34" charset="0"/>
@@ -12679,7 +12136,9 @@
                   <a:noFill/>
                 </a:ln>
                 <a:solidFill>
-                  <a:schemeClr val="tx1"/>
+                  <a:schemeClr val="bg1">
+                    <a:lumMod val="95000"/>
+                  </a:schemeClr>
                 </a:solidFill>
                 <a:effectLst/>
                 <a:latin typeface="Arial" panose="020B0604020202020204" pitchFamily="34" charset="0"/>
@@ -12692,7 +12151,9 @@
                   <a:noFill/>
                 </a:ln>
                 <a:solidFill>
-                  <a:schemeClr val="tx1"/>
+                  <a:schemeClr val="bg1">
+                    <a:lumMod val="95000"/>
+                  </a:schemeClr>
                 </a:solidFill>
                 <a:effectLst/>
                 <a:latin typeface="Arial" panose="020B0604020202020204" pitchFamily="34" charset="0"/>
@@ -12705,7 +12166,9 @@
                   <a:noFill/>
                 </a:ln>
                 <a:solidFill>
-                  <a:schemeClr val="tx1"/>
+                  <a:schemeClr val="bg1">
+                    <a:lumMod val="95000"/>
+                  </a:schemeClr>
                 </a:solidFill>
                 <a:effectLst/>
                 <a:latin typeface="Arial" panose="020B0604020202020204" pitchFamily="34" charset="0"/>
@@ -12718,7 +12181,9 @@
                   <a:noFill/>
                 </a:ln>
                 <a:solidFill>
-                  <a:schemeClr val="tx1"/>
+                  <a:schemeClr val="bg1">
+                    <a:lumMod val="95000"/>
+                  </a:schemeClr>
                 </a:solidFill>
                 <a:effectLst/>
                 <a:latin typeface="Arial" panose="020B0604020202020204" pitchFamily="34" charset="0"/>
@@ -12731,7 +12196,9 @@
                   <a:noFill/>
                 </a:ln>
                 <a:solidFill>
-                  <a:schemeClr val="tx1"/>
+                  <a:schemeClr val="bg1">
+                    <a:lumMod val="95000"/>
+                  </a:schemeClr>
                 </a:solidFill>
                 <a:effectLst/>
                 <a:latin typeface="Arial" panose="020B0604020202020204" pitchFamily="34" charset="0"/>
@@ -12744,7 +12211,9 @@
                   <a:noFill/>
                 </a:ln>
                 <a:solidFill>
-                  <a:schemeClr val="tx1"/>
+                  <a:schemeClr val="bg1">
+                    <a:lumMod val="95000"/>
+                  </a:schemeClr>
                 </a:solidFill>
                 <a:effectLst/>
                 <a:latin typeface="Arial" panose="020B0604020202020204" pitchFamily="34" charset="0"/>
@@ -12757,7 +12226,9 @@
                   <a:noFill/>
                 </a:ln>
                 <a:solidFill>
-                  <a:schemeClr val="tx1"/>
+                  <a:schemeClr val="bg1">
+                    <a:lumMod val="95000"/>
+                  </a:schemeClr>
                 </a:solidFill>
                 <a:effectLst/>
                 <a:latin typeface="Arial" panose="020B0604020202020204" pitchFamily="34" charset="0"/>
@@ -12770,7 +12241,9 @@
                   <a:noFill/>
                 </a:ln>
                 <a:solidFill>
-                  <a:schemeClr val="tx1"/>
+                  <a:schemeClr val="bg1">
+                    <a:lumMod val="95000"/>
+                  </a:schemeClr>
                 </a:solidFill>
                 <a:effectLst/>
                 <a:latin typeface="Arial" panose="020B0604020202020204" pitchFamily="34" charset="0"/>
@@ -12783,7 +12256,9 @@
                   <a:noFill/>
                 </a:ln>
                 <a:solidFill>
-                  <a:schemeClr val="tx1"/>
+                  <a:schemeClr val="bg1">
+                    <a:lumMod val="95000"/>
+                  </a:schemeClr>
                 </a:solidFill>
                 <a:effectLst/>
                 <a:latin typeface="Arial" panose="020B0604020202020204" pitchFamily="34" charset="0"/>
@@ -12796,7 +12271,9 @@
                   <a:noFill/>
                 </a:ln>
                 <a:solidFill>
-                  <a:schemeClr val="tx1"/>
+                  <a:schemeClr val="bg1">
+                    <a:lumMod val="95000"/>
+                  </a:schemeClr>
                 </a:solidFill>
                 <a:effectLst/>
                 <a:latin typeface="Arial" panose="020B0604020202020204" pitchFamily="34" charset="0"/>
@@ -12808,7 +12285,9 @@
                   <a:noFill/>
                 </a:ln>
                 <a:solidFill>
-                  <a:schemeClr val="tx1"/>
+                  <a:schemeClr val="bg1">
+                    <a:lumMod val="95000"/>
+                  </a:schemeClr>
                 </a:solidFill>
                 <a:effectLst/>
                 <a:latin typeface="Arial" panose="020B0604020202020204" pitchFamily="34" charset="0"/>
@@ -12821,7 +12300,9 @@
                   <a:noFill/>
                 </a:ln>
                 <a:solidFill>
-                  <a:schemeClr val="tx1"/>
+                  <a:schemeClr val="bg1">
+                    <a:lumMod val="95000"/>
+                  </a:schemeClr>
                 </a:solidFill>
                 <a:effectLst/>
                 <a:latin typeface="Arial Unicode MS"/>
@@ -12834,7 +12315,9 @@
                   <a:noFill/>
                 </a:ln>
                 <a:solidFill>
-                  <a:schemeClr val="tx1"/>
+                  <a:schemeClr val="bg1">
+                    <a:lumMod val="95000"/>
+                  </a:schemeClr>
                 </a:solidFill>
                 <a:effectLst/>
               </a:rPr>
@@ -12846,7 +12329,9 @@
                   <a:noFill/>
                 </a:ln>
                 <a:solidFill>
-                  <a:schemeClr val="tx1"/>
+                  <a:schemeClr val="bg1">
+                    <a:lumMod val="95000"/>
+                  </a:schemeClr>
                 </a:solidFill>
                 <a:effectLst/>
                 <a:latin typeface="Arial Unicode MS"/>
@@ -12859,7 +12344,9 @@
                   <a:noFill/>
                 </a:ln>
                 <a:solidFill>
-                  <a:schemeClr val="tx1"/>
+                  <a:schemeClr val="bg1">
+                    <a:lumMod val="95000"/>
+                  </a:schemeClr>
                 </a:solidFill>
                 <a:effectLst/>
               </a:rPr>
@@ -12871,7 +12358,9 @@
                   <a:noFill/>
                 </a:ln>
                 <a:solidFill>
-                  <a:schemeClr val="tx1"/>
+                  <a:schemeClr val="bg1">
+                    <a:lumMod val="95000"/>
+                  </a:schemeClr>
                 </a:solidFill>
                 <a:effectLst/>
                 <a:latin typeface="Arial" panose="020B0604020202020204" pitchFamily="34" charset="0"/>
@@ -12883,7 +12372,9 @@
                   <a:noFill/>
                 </a:ln>
                 <a:solidFill>
-                  <a:schemeClr val="tx1"/>
+                  <a:schemeClr val="bg1">
+                    <a:lumMod val="95000"/>
+                  </a:schemeClr>
                 </a:solidFill>
                 <a:effectLst/>
                 <a:latin typeface="Arial" panose="020B0604020202020204" pitchFamily="34" charset="0"/>
@@ -12911,7 +12402,9 @@
             <a:r>
               <a:rPr lang="en-US" altLang="en-US" sz="1800" dirty="0">
                 <a:solidFill>
-                  <a:schemeClr val="tx1"/>
+                  <a:schemeClr val="bg1">
+                    <a:lumMod val="95000"/>
+                  </a:schemeClr>
                 </a:solidFill>
                 <a:latin typeface="Arial" panose="020B0604020202020204" pitchFamily="34" charset="0"/>
               </a:rPr>
@@ -12922,7 +12415,9 @@
                 <a:noFill/>
               </a:ln>
               <a:solidFill>
-                <a:schemeClr val="tx1"/>
+                <a:schemeClr val="bg1">
+                  <a:lumMod val="95000"/>
+                </a:schemeClr>
               </a:solidFill>
               <a:effectLst/>
               <a:latin typeface="Arial" panose="020B0604020202020204" pitchFamily="34" charset="0"/>
@@ -12972,6 +12467,93 @@
 </file>
 
 <file path=ppt/slides/slide8.xml><?xml version="1.0" encoding="utf-8"?>
+<p:sld xmlns:a="http://schemas.openxmlformats.org/drawingml/2006/main" xmlns:r="http://schemas.openxmlformats.org/officeDocument/2006/relationships" xmlns:p="http://schemas.openxmlformats.org/presentationml/2006/main">
+  <p:cSld>
+    <p:spTree>
+      <p:nvGrpSpPr>
+        <p:cNvPr id="1" name=""/>
+        <p:cNvGrpSpPr/>
+        <p:nvPr/>
+      </p:nvGrpSpPr>
+      <p:grpSpPr>
+        <a:xfrm>
+          <a:off x="0" y="0"/>
+          <a:ext cx="0" cy="0"/>
+          <a:chOff x="0" y="0"/>
+          <a:chExt cx="0" cy="0"/>
+        </a:xfrm>
+      </p:grpSpPr>
+      <p:sp>
+        <p:nvSpPr>
+          <p:cNvPr id="2" name="Title 1">
+            <a:extLst>
+              <a:ext uri="{FF2B5EF4-FFF2-40B4-BE49-F238E27FC236}">
+                <a16:creationId xmlns:a16="http://schemas.microsoft.com/office/drawing/2014/main" id="{CA8A35A4-DCD3-0017-C9B6-494058E2009D}"/>
+              </a:ext>
+            </a:extLst>
+          </p:cNvPr>
+          <p:cNvSpPr>
+            <a:spLocks noGrp="1"/>
+          </p:cNvSpPr>
+          <p:nvPr>
+            <p:ph type="title"/>
+          </p:nvPr>
+        </p:nvSpPr>
+        <p:spPr/>
+        <p:txBody>
+          <a:bodyPr/>
+          <a:lstStyle/>
+          <a:p>
+            <a:r>
+              <a:rPr lang="en-US" dirty="0"/>
+              <a:t>User Story #3 - Tracking Income</a:t>
+            </a:r>
+          </a:p>
+        </p:txBody>
+      </p:sp>
+      <p:pic>
+        <p:nvPicPr>
+          <p:cNvPr id="4" name="Content Placeholder 4">
+            <a:extLst>
+              <a:ext uri="{FF2B5EF4-FFF2-40B4-BE49-F238E27FC236}">
+                <a16:creationId xmlns:a16="http://schemas.microsoft.com/office/drawing/2014/main" id="{07DF7CA4-14D2-D13F-D18D-C23123B1CFC4}"/>
+              </a:ext>
+            </a:extLst>
+          </p:cNvPr>
+          <p:cNvPicPr>
+            <a:picLocks noGrp="1" noChangeAspect="1"/>
+          </p:cNvPicPr>
+          <p:nvPr>
+            <p:ph idx="1"/>
+          </p:nvPr>
+        </p:nvPicPr>
+        <p:blipFill>
+          <a:blip r:embed="rId2"/>
+          <a:stretch>
+            <a:fillRect/>
+          </a:stretch>
+        </p:blipFill>
+        <p:spPr>
+          <a:xfrm>
+            <a:off x="1567749" y="2126840"/>
+            <a:ext cx="5615371" cy="4538805"/>
+          </a:xfrm>
+        </p:spPr>
+      </p:pic>
+    </p:spTree>
+    <p:extLst>
+      <p:ext uri="{BB962C8B-B14F-4D97-AF65-F5344CB8AC3E}">
+        <p14:creationId xmlns:p14="http://schemas.microsoft.com/office/powerpoint/2010/main" val="266967733"/>
+      </p:ext>
+    </p:extLst>
+  </p:cSld>
+  <p:clrMapOvr>
+    <a:masterClrMapping/>
+  </p:clrMapOvr>
+</p:sld>
+</file>
+
+<file path=ppt/slides/slide9.xml><?xml version="1.0" encoding="utf-8"?>
 <p:sld xmlns:a="http://schemas.openxmlformats.org/drawingml/2006/main" xmlns:r="http://schemas.openxmlformats.org/officeDocument/2006/relationships" xmlns:p="http://schemas.openxmlformats.org/presentationml/2006/main">
   <p:cSld>
     <p:spTree>
@@ -13127,354 +12709,6 @@
     <p:extLst>
       <p:ext uri="{BB962C8B-B14F-4D97-AF65-F5344CB8AC3E}">
         <p14:creationId xmlns:p14="http://schemas.microsoft.com/office/powerpoint/2010/main" val="776019389"/>
-      </p:ext>
-    </p:extLst>
-  </p:cSld>
-  <p:clrMapOvr>
-    <a:masterClrMapping/>
-  </p:clrMapOvr>
-</p:sld>
-</file>
-
-<file path=ppt/slides/slide9.xml><?xml version="1.0" encoding="utf-8"?>
-<p:sld xmlns:a="http://schemas.openxmlformats.org/drawingml/2006/main" xmlns:r="http://schemas.openxmlformats.org/officeDocument/2006/relationships" xmlns:p="http://schemas.openxmlformats.org/presentationml/2006/main">
-  <p:cSld>
-    <p:spTree>
-      <p:nvGrpSpPr>
-        <p:cNvPr id="1" name=""/>
-        <p:cNvGrpSpPr/>
-        <p:nvPr/>
-      </p:nvGrpSpPr>
-      <p:grpSpPr>
-        <a:xfrm>
-          <a:off x="0" y="0"/>
-          <a:ext cx="0" cy="0"/>
-          <a:chOff x="0" y="0"/>
-          <a:chExt cx="0" cy="0"/>
-        </a:xfrm>
-      </p:grpSpPr>
-      <p:sp>
-        <p:nvSpPr>
-          <p:cNvPr id="6" name="Title 5">
-            <a:extLst>
-              <a:ext uri="{FF2B5EF4-FFF2-40B4-BE49-F238E27FC236}">
-                <a16:creationId xmlns:a16="http://schemas.microsoft.com/office/drawing/2014/main" id="{EDF9E134-98AA-3ECE-E40A-180C85ACD7D5}"/>
-              </a:ext>
-            </a:extLst>
-          </p:cNvPr>
-          <p:cNvSpPr>
-            <a:spLocks noGrp="1"/>
-          </p:cNvSpPr>
-          <p:nvPr>
-            <p:ph type="title"/>
-          </p:nvPr>
-        </p:nvSpPr>
-        <p:spPr>
-          <a:xfrm>
-            <a:off x="1167492" y="136526"/>
-            <a:ext cx="9601200" cy="1653371"/>
-          </a:xfrm>
-        </p:spPr>
-        <p:txBody>
-          <a:bodyPr/>
-          <a:lstStyle/>
-          <a:p>
-            <a:r>
-              <a:rPr lang="en-US" dirty="0"/>
-              <a:t>SOLID Principles</a:t>
-            </a:r>
-          </a:p>
-        </p:txBody>
-      </p:sp>
-      <p:sp>
-        <p:nvSpPr>
-          <p:cNvPr id="8" name="Rectangle 2">
-            <a:extLst>
-              <a:ext uri="{FF2B5EF4-FFF2-40B4-BE49-F238E27FC236}">
-                <a16:creationId xmlns:a16="http://schemas.microsoft.com/office/drawing/2014/main" id="{C18C8363-1151-CA2E-E25A-AAE513C9627F}"/>
-              </a:ext>
-            </a:extLst>
-          </p:cNvPr>
-          <p:cNvSpPr>
-            <a:spLocks noGrp="1" noChangeArrowheads="1"/>
-          </p:cNvSpPr>
-          <p:nvPr>
-            <p:ph idx="1"/>
-          </p:nvPr>
-        </p:nvSpPr>
-        <p:spPr bwMode="auto">
-          <a:xfrm>
-            <a:off x="1166813" y="2489815"/>
-            <a:ext cx="9353703" cy="2400657"/>
-          </a:xfrm>
-          <a:prstGeom prst="rect">
-            <a:avLst/>
-          </a:prstGeom>
-          <a:noFill/>
-          <a:ln>
-            <a:noFill/>
-          </a:ln>
-          <a:effectLst/>
-          <a:extLst>
-            <a:ext uri="{909E8E84-426E-40DD-AFC4-6F175D3DCCD1}">
-              <a14:hiddenFill xmlns:a14="http://schemas.microsoft.com/office/drawing/2010/main">
-                <a:solidFill>
-                  <a:schemeClr val="accent1"/>
-                </a:solidFill>
-              </a14:hiddenFill>
-            </a:ext>
-            <a:ext uri="{91240B29-F687-4F45-9708-019B960494DF}">
-              <a14:hiddenLine xmlns:a14="http://schemas.microsoft.com/office/drawing/2010/main" w="9525">
-                <a:solidFill>
-                  <a:schemeClr val="tx1"/>
-                </a:solidFill>
-                <a:miter lim="800000"/>
-                <a:headEnd/>
-                <a:tailEnd/>
-              </a14:hiddenLine>
-            </a:ext>
-            <a:ext uri="{AF507438-7753-43E0-B8FC-AC1667EBCBE1}">
-              <a14:hiddenEffects xmlns:a14="http://schemas.microsoft.com/office/drawing/2010/main">
-                <a:effectLst>
-                  <a:outerShdw dist="35921" dir="2700000" algn="ctr" rotWithShape="0">
-                    <a:schemeClr val="bg2"/>
-                  </a:outerShdw>
-                </a:effectLst>
-              </a14:hiddenEffects>
-            </a:ext>
-          </a:extLst>
-        </p:spPr>
-        <p:txBody>
-          <a:bodyPr vert="horz" wrap="square" lIns="91440" tIns="45720" rIns="91440" bIns="45720" numCol="1" anchor="ctr" anchorCtr="0" compatLnSpc="1">
-            <a:prstTxWarp prst="textNoShape">
-              <a:avLst/>
-            </a:prstTxWarp>
-            <a:spAutoFit/>
-          </a:bodyPr>
-          <a:lstStyle/>
-          <a:p>
-            <a:pPr marL="0" marR="0" lvl="0" indent="0" algn="l" defTabSz="914400" rtl="0" eaLnBrk="0" fontAlgn="base" latinLnBrk="0" hangingPunct="0">
-              <a:lnSpc>
-                <a:spcPct val="100000"/>
-              </a:lnSpc>
-              <a:spcBef>
-                <a:spcPct val="0"/>
-              </a:spcBef>
-              <a:spcAft>
-                <a:spcPct val="0"/>
-              </a:spcAft>
-              <a:buClrTx/>
-              <a:buSzTx/>
-              <a:buFontTx/>
-              <a:buNone/>
-              <a:tabLst/>
-            </a:pPr>
-            <a:r>
-              <a:rPr kumimoji="0" lang="en-US" altLang="en-US" sz="2500" b="0" i="0" u="none" strike="noStrike" cap="none" normalizeH="0" baseline="0" dirty="0">
-                <a:ln>
-                  <a:noFill/>
-                </a:ln>
-                <a:solidFill>
-                  <a:schemeClr val="tx1"/>
-                </a:solidFill>
-                <a:effectLst/>
-                <a:latin typeface="Arial" panose="020B0604020202020204" pitchFamily="34" charset="0"/>
-              </a:rPr>
-              <a:t>Applies all five SOLID principles for clean and maintainable code.</a:t>
-            </a:r>
-            <a:br>
-              <a:rPr kumimoji="0" lang="en-US" altLang="en-US" sz="2500" b="0" i="0" u="none" strike="noStrike" cap="none" normalizeH="0" baseline="0" dirty="0">
-                <a:ln>
-                  <a:noFill/>
-                </a:ln>
-                <a:solidFill>
-                  <a:schemeClr val="tx1"/>
-                </a:solidFill>
-                <a:effectLst/>
-                <a:latin typeface="Arial" panose="020B0604020202020204" pitchFamily="34" charset="0"/>
-              </a:rPr>
-            </a:br>
-            <a:r>
-              <a:rPr kumimoji="0" lang="en-US" altLang="en-US" sz="2500" b="0" i="0" u="none" strike="noStrike" cap="none" normalizeH="0" baseline="0" dirty="0">
-                <a:ln>
-                  <a:noFill/>
-                </a:ln>
-                <a:solidFill>
-                  <a:schemeClr val="tx1"/>
-                </a:solidFill>
-                <a:effectLst/>
-                <a:latin typeface="Arial" panose="020B0604020202020204" pitchFamily="34" charset="0"/>
-              </a:rPr>
-              <a:t>Example: </a:t>
-            </a:r>
-            <a:r>
-              <a:rPr kumimoji="0" lang="en-US" altLang="en-US" sz="2500" b="1" i="0" u="none" strike="noStrike" cap="none" normalizeH="0" baseline="0" dirty="0" err="1">
-                <a:ln>
-                  <a:noFill/>
-                </a:ln>
-                <a:solidFill>
-                  <a:schemeClr val="tx1"/>
-                </a:solidFill>
-                <a:effectLst/>
-                <a:latin typeface="Arial Unicode MS"/>
-              </a:rPr>
-              <a:t>AuthManager</a:t>
-            </a:r>
-            <a:r>
-              <a:rPr kumimoji="0" lang="en-US" altLang="en-US" sz="2500" b="0" i="0" u="none" strike="noStrike" cap="none" normalizeH="0" baseline="0" dirty="0">
-                <a:ln>
-                  <a:noFill/>
-                </a:ln>
-                <a:solidFill>
-                  <a:schemeClr val="tx1"/>
-                </a:solidFill>
-                <a:effectLst/>
-              </a:rPr>
-              <a:t> follows </a:t>
-            </a:r>
-            <a:r>
-              <a:rPr kumimoji="0" lang="en-US" altLang="en-US" sz="2500" b="1" i="0" u="none" strike="noStrike" cap="none" normalizeH="0" baseline="0" dirty="0">
-                <a:ln>
-                  <a:noFill/>
-                </a:ln>
-                <a:solidFill>
-                  <a:schemeClr val="tx1"/>
-                </a:solidFill>
-                <a:effectLst/>
-              </a:rPr>
-              <a:t>Single Responsibility</a:t>
-            </a:r>
-            <a:r>
-              <a:rPr kumimoji="0" lang="en-US" altLang="en-US" sz="2500" b="0" i="0" u="none" strike="noStrike" cap="none" normalizeH="0" baseline="0" dirty="0">
-                <a:ln>
-                  <a:noFill/>
-                </a:ln>
-                <a:solidFill>
-                  <a:schemeClr val="tx1"/>
-                </a:solidFill>
-                <a:effectLst/>
-              </a:rPr>
-              <a:t>, and </a:t>
-            </a:r>
-            <a:r>
-              <a:rPr kumimoji="0" lang="en-US" altLang="en-US" sz="2500" b="1" i="0" u="none" strike="noStrike" cap="none" normalizeH="0" baseline="0" dirty="0" err="1">
-                <a:ln>
-                  <a:noFill/>
-                </a:ln>
-                <a:solidFill>
-                  <a:schemeClr val="tx1"/>
-                </a:solidFill>
-                <a:effectLst/>
-                <a:latin typeface="Arial Unicode MS"/>
-              </a:rPr>
-              <a:t>IManager</a:t>
-            </a:r>
-            <a:r>
-              <a:rPr kumimoji="0" lang="en-US" altLang="en-US" sz="2500" b="0" i="0" u="none" strike="noStrike" cap="none" normalizeH="0" baseline="0" dirty="0">
-                <a:ln>
-                  <a:noFill/>
-                </a:ln>
-                <a:solidFill>
-                  <a:schemeClr val="tx1"/>
-                </a:solidFill>
-                <a:effectLst/>
-              </a:rPr>
-              <a:t> supports </a:t>
-            </a:r>
-            <a:r>
-              <a:rPr kumimoji="0" lang="en-US" altLang="en-US" sz="2500" b="1" i="0" u="none" strike="noStrike" cap="none" normalizeH="0" baseline="0" dirty="0">
-                <a:ln>
-                  <a:noFill/>
-                </a:ln>
-                <a:solidFill>
-                  <a:schemeClr val="tx1"/>
-                </a:solidFill>
-                <a:effectLst/>
-              </a:rPr>
-              <a:t>Interface Segregation</a:t>
-            </a:r>
-            <a:r>
-              <a:rPr kumimoji="0" lang="en-US" altLang="en-US" sz="2500" b="0" i="0" u="none" strike="noStrike" cap="none" normalizeH="0" baseline="0" dirty="0">
-                <a:ln>
-                  <a:noFill/>
-                </a:ln>
-                <a:solidFill>
-                  <a:schemeClr val="tx1"/>
-                </a:solidFill>
-                <a:effectLst/>
-              </a:rPr>
-              <a:t>.</a:t>
-            </a:r>
-            <a:br>
-              <a:rPr kumimoji="0" lang="en-US" altLang="en-US" sz="2500" b="0" i="0" u="none" strike="noStrike" cap="none" normalizeH="0" baseline="0" dirty="0">
-                <a:ln>
-                  <a:noFill/>
-                </a:ln>
-                <a:solidFill>
-                  <a:schemeClr val="tx1"/>
-                </a:solidFill>
-                <a:effectLst/>
-                <a:latin typeface="Arial" panose="020B0604020202020204" pitchFamily="34" charset="0"/>
-              </a:rPr>
-            </a:br>
-            <a:r>
-              <a:rPr kumimoji="0" lang="en-US" altLang="en-US" sz="2500" b="1" i="0" u="none" strike="noStrike" cap="none" normalizeH="0" baseline="0" dirty="0">
-                <a:ln>
-                  <a:noFill/>
-                </a:ln>
-                <a:solidFill>
-                  <a:schemeClr val="tx1"/>
-                </a:solidFill>
-                <a:effectLst/>
-                <a:latin typeface="Arial" panose="020B0604020202020204" pitchFamily="34" charset="0"/>
-              </a:rPr>
-              <a:t>Open/Closed principle </a:t>
-            </a:r>
-            <a:r>
-              <a:rPr kumimoji="0" lang="en-US" altLang="en-US" sz="2500" b="0" i="0" u="none" strike="noStrike" cap="none" normalizeH="0" baseline="0" dirty="0">
-                <a:ln>
-                  <a:noFill/>
-                </a:ln>
-                <a:solidFill>
-                  <a:schemeClr val="tx1"/>
-                </a:solidFill>
-                <a:effectLst/>
-                <a:latin typeface="Arial" panose="020B0604020202020204" pitchFamily="34" charset="0"/>
-              </a:rPr>
-              <a:t>is applied by extending without modifying existing classes.</a:t>
-            </a:r>
-            <a:br>
-              <a:rPr kumimoji="0" lang="en-US" altLang="en-US" sz="2500" b="0" i="0" u="none" strike="noStrike" cap="none" normalizeH="0" baseline="0" dirty="0">
-                <a:ln>
-                  <a:noFill/>
-                </a:ln>
-                <a:solidFill>
-                  <a:schemeClr val="tx1"/>
-                </a:solidFill>
-                <a:effectLst/>
-                <a:latin typeface="Arial" panose="020B0604020202020204" pitchFamily="34" charset="0"/>
-              </a:rPr>
-            </a:br>
-            <a:r>
-              <a:rPr kumimoji="0" lang="en-US" altLang="en-US" sz="2500" b="0" i="0" u="none" strike="noStrike" cap="none" normalizeH="0" baseline="0" dirty="0">
-                <a:ln>
-                  <a:noFill/>
-                </a:ln>
-                <a:solidFill>
-                  <a:schemeClr val="tx1"/>
-                </a:solidFill>
-                <a:effectLst/>
-                <a:latin typeface="Arial" panose="020B0604020202020204" pitchFamily="34" charset="0"/>
-              </a:rPr>
-              <a:t>Encourages modular, testable, and scalable design. </a:t>
-            </a:r>
-          </a:p>
-        </p:txBody>
-      </p:sp>
-    </p:spTree>
-    <p:extLst>
-      <p:ext uri="{BB962C8B-B14F-4D97-AF65-F5344CB8AC3E}">
-        <p14:creationId xmlns:p14="http://schemas.microsoft.com/office/powerpoint/2010/main" val="1265939620"/>
       </p:ext>
     </p:extLst>
   </p:cSld>
@@ -14276,23 +13510,12 @@
 </file>
 
 <file path=customXml/item1.xml><?xml version="1.0" encoding="utf-8"?>
-<p:properties xmlns:p="http://schemas.microsoft.com/office/2006/metadata/properties" xmlns:xsi="http://www.w3.org/2001/XMLSchema-instance" xmlns:pc="http://schemas.microsoft.com/office/infopath/2007/PartnerControls">
-  <documentManagement>
-    <_ip_UnifiedCompliancePolicyUIAction xmlns="http://schemas.microsoft.com/sharepoint/v3" xsi:nil="true"/>
-    <Image xmlns="71af3243-3dd4-4a8d-8c0d-dd76da1f02a5">
-      <Url xsi:nil="true"/>
-      <Description xsi:nil="true"/>
-    </Image>
-    <Status xmlns="71af3243-3dd4-4a8d-8c0d-dd76da1f02a5">Not started</Status>
-    <Background xmlns="71af3243-3dd4-4a8d-8c0d-dd76da1f02a5">false</Background>
-    <_ip_UnifiedCompliancePolicyProperties xmlns="http://schemas.microsoft.com/sharepoint/v3" xsi:nil="true"/>
-    <ImageTagsTaxHTField xmlns="71af3243-3dd4-4a8d-8c0d-dd76da1f02a5">
-      <Terms xmlns="http://schemas.microsoft.com/office/infopath/2007/PartnerControls"/>
-    </ImageTagsTaxHTField>
-    <TaxCatchAll xmlns="230e9df3-be65-4c73-a93b-d1236ebd677e" xsi:nil="true"/>
-    <MediaServiceKeyPoints xmlns="71af3243-3dd4-4a8d-8c0d-dd76da1f02a5" xsi:nil="true"/>
-  </documentManagement>
-</p:properties>
+<?mso-contentType ?>
+<FormTemplates xmlns="http://schemas.microsoft.com/sharepoint/v3/contenttype/forms">
+  <Display>DocumentLibraryForm</Display>
+  <Edit>DocumentLibraryForm</Edit>
+  <New>DocumentLibraryForm</New>
+</FormTemplates>
 </file>
 
 <file path=customXml/item2.xml><?xml version="1.0" encoding="utf-8"?>
@@ -14608,22 +13831,29 @@
 </file>
 
 <file path=customXml/item3.xml><?xml version="1.0" encoding="utf-8"?>
-<?mso-contentType ?>
-<FormTemplates xmlns="http://schemas.microsoft.com/sharepoint/v3/contenttype/forms">
-  <Display>DocumentLibraryForm</Display>
-  <Edit>DocumentLibraryForm</Edit>
-  <New>DocumentLibraryForm</New>
-</FormTemplates>
+<p:properties xmlns:p="http://schemas.microsoft.com/office/2006/metadata/properties" xmlns:xsi="http://www.w3.org/2001/XMLSchema-instance" xmlns:pc="http://schemas.microsoft.com/office/infopath/2007/PartnerControls">
+  <documentManagement>
+    <_ip_UnifiedCompliancePolicyUIAction xmlns="http://schemas.microsoft.com/sharepoint/v3" xsi:nil="true"/>
+    <Image xmlns="71af3243-3dd4-4a8d-8c0d-dd76da1f02a5">
+      <Url xsi:nil="true"/>
+      <Description xsi:nil="true"/>
+    </Image>
+    <Status xmlns="71af3243-3dd4-4a8d-8c0d-dd76da1f02a5">Not started</Status>
+    <Background xmlns="71af3243-3dd4-4a8d-8c0d-dd76da1f02a5">false</Background>
+    <_ip_UnifiedCompliancePolicyProperties xmlns="http://schemas.microsoft.com/sharepoint/v3" xsi:nil="true"/>
+    <ImageTagsTaxHTField xmlns="71af3243-3dd4-4a8d-8c0d-dd76da1f02a5">
+      <Terms xmlns="http://schemas.microsoft.com/office/infopath/2007/PartnerControls"/>
+    </ImageTagsTaxHTField>
+    <TaxCatchAll xmlns="230e9df3-be65-4c73-a93b-d1236ebd677e" xsi:nil="true"/>
+    <MediaServiceKeyPoints xmlns="71af3243-3dd4-4a8d-8c0d-dd76da1f02a5" xsi:nil="true"/>
+  </documentManagement>
+</p:properties>
 </file>
 
 <file path=customXml/itemProps1.xml><?xml version="1.0" encoding="utf-8"?>
-<ds:datastoreItem xmlns:ds="http://schemas.openxmlformats.org/officeDocument/2006/customXml" ds:itemID="{61E98C35-9ECE-4425-BCBA-00E118C705CE}">
+<ds:datastoreItem xmlns:ds="http://schemas.openxmlformats.org/officeDocument/2006/customXml" ds:itemID="{45A8381C-73EB-48EA-B45F-7B7C8C7DF409}">
   <ds:schemaRefs>
-    <ds:schemaRef ds:uri="http://schemas.microsoft.com/office/2006/metadata/properties"/>
-    <ds:schemaRef ds:uri="http://schemas.microsoft.com/office/infopath/2007/PartnerControls"/>
-    <ds:schemaRef ds:uri="http://schemas.microsoft.com/sharepoint/v3"/>
-    <ds:schemaRef ds:uri="71af3243-3dd4-4a8d-8c0d-dd76da1f02a5"/>
-    <ds:schemaRef ds:uri="230e9df3-be65-4c73-a93b-d1236ebd677e"/>
+    <ds:schemaRef ds:uri="http://schemas.microsoft.com/sharepoint/v3/contenttype/forms"/>
   </ds:schemaRefs>
 </ds:datastoreItem>
 </file>
@@ -14650,9 +13880,13 @@
 </file>
 
 <file path=customXml/itemProps3.xml><?xml version="1.0" encoding="utf-8"?>
-<ds:datastoreItem xmlns:ds="http://schemas.openxmlformats.org/officeDocument/2006/customXml" ds:itemID="{45A8381C-73EB-48EA-B45F-7B7C8C7DF409}">
+<ds:datastoreItem xmlns:ds="http://schemas.openxmlformats.org/officeDocument/2006/customXml" ds:itemID="{61E98C35-9ECE-4425-BCBA-00E118C705CE}">
   <ds:schemaRefs>
-    <ds:schemaRef ds:uri="http://schemas.microsoft.com/sharepoint/v3/contenttype/forms"/>
+    <ds:schemaRef ds:uri="http://schemas.microsoft.com/office/2006/metadata/properties"/>
+    <ds:schemaRef ds:uri="http://schemas.microsoft.com/office/infopath/2007/PartnerControls"/>
+    <ds:schemaRef ds:uri="http://schemas.microsoft.com/sharepoint/v3"/>
+    <ds:schemaRef ds:uri="71af3243-3dd4-4a8d-8c0d-dd76da1f02a5"/>
+    <ds:schemaRef ds:uri="230e9df3-be65-4c73-a93b-d1236ebd677e"/>
   </ds:schemaRefs>
 </ds:datastoreItem>
 </file>

</xml_diff>